<commit_message>
Rewrite presentation around the student problem, without technical detail
Co-Authored-By: Claude Opus 5.5 <noreply@anthropic.com>
Claude-Session: https://claude.ai/code/session_019gPhNF3CE9nwEznmCvTmpj
</commit_message>
<xml_diff>
--- a/docs/TerraTeach.pptx
+++ b/docs/TerraTeach.pptx
@@ -13,9 +13,10 @@
     <p:sldId id="261" r:id="rId7"/>
     <p:sldId id="262" r:id="rId8"/>
     <p:sldId id="263" r:id="rId9"/>
+    <p:sldId id="264" r:id="rId10"/>
   </p:sldIdLst>
   <p:notesMasterIdLst>
-    <p:notesMasterId r:id="rId10"/>
+    <p:notesMasterId r:id="rId11"/>
   </p:notesMasterIdLst>
   <p:sldSz cx="9144000" cy="5143500"/>
   <p:notesSz cx="5143500" cy="9144000"/>
@@ -114,28 +115,29 @@
   <p:extLst>
     <p:ext uri="{521415D9-36F7-43E2-AB2F-B90AF26B5E84}">
       <p14:sectionLst xmlns:p14="http://schemas.microsoft.com/office/powerpoint/2010/main">
-        <p14:section name="Intro" id="{79163fec-9e6f-829a-a544-64e3018deee5}">
+        <p14:section name="The problem" id="{a9036d2d-0e1e-25da-2017-b93ae07c2a45}">
           <p14:sldIdLst>
             <p14:sldId id="256"/>
             <p14:sldId id="257"/>
           </p14:sldIdLst>
         </p14:section>
-        <p14:section name="Features" id="{be57dd44-2f82-c2f9-7ce1-d639eff928a9}">
+        <p14:section name="Our solution" id="{1824728b-23e6-06e3-0a06-b075d270d585}">
           <p14:sldIdLst>
             <p14:sldId id="258"/>
             <p14:sldId id="259"/>
             <p14:sldId id="260"/>
-          </p14:sldIdLst>
-        </p14:section>
-        <p14:section name="How it works" id="{6de62f34-fe54-cfac-32d4-34d634e65c3b}">
-          <p14:sldIdLst>
             <p14:sldId id="261"/>
             <p14:sldId id="262"/>
           </p14:sldIdLst>
         </p14:section>
-        <p14:section name="Next steps" id="{2af1b926-ed23-2375-0832-764c949785fe}">
+        <p14:section name="Impact" id="{abb3cd7c-9ee3-e5c5-c8fd-cb4dad246a27}">
           <p14:sldIdLst>
             <p14:sldId id="263"/>
+          </p14:sldIdLst>
+        </p14:section>
+        <p14:section name="Next steps" id="{805b7f4d-d337-ce5a-82ba-d5048a8726bb}">
+          <p14:sldIdLst>
+            <p14:sldId id="264"/>
           </p14:sldIdLst>
         </p14:section>
       </p14:sectionLst>
@@ -542,7 +544,7 @@
           <a:p>
             <a:r>
               <a:rPr lang="en-US" dirty="0"/>
-              <a:t>TerraTeach is a desktop web app that turns a blank India map into an interactive classroom tool.</a:t>
+              <a:t/>
             </a:r>
             <a:endParaRPr lang="en-US" dirty="0"/>
           </a:p>
@@ -1182,6 +1184,94 @@
             <a:fld id="{F7021451-1387-4CA6-816F-3879F97B5CBC}" type="slidenum">
               <a:rPr lang="en-US"/>
               <a:t>8</a:t>
+            </a:fld>
+            <a:endParaRPr lang="en-US"/>
+          </a:p>
+        </p:txBody>
+      </p:sp>
+    </p:spTree>
+    <p:extLst>
+      <p:ext uri="{BB962C8B-B14F-4D97-AF65-F5344CB8AC3E}">
+        <p14:creationId xmlns:p14="http://schemas.microsoft.com/office/powerpoint/2010/main" val="1024086991"/>
+      </p:ext>
+    </p:extLst>
+  </p:cSld>
+  <p:clrMapOvr>
+    <a:masterClrMapping/>
+  </p:clrMapOvr>
+</p:notes>
+</file>
+
+<file path=ppt/notesSlides/notesSlide9.xml><?xml version="1.0" encoding="utf-8"?>
+<p:notes xmlns:a="http://schemas.openxmlformats.org/drawingml/2006/main" xmlns:r="http://schemas.openxmlformats.org/officeDocument/2006/relationships" xmlns:p="http://schemas.openxmlformats.org/presentationml/2006/main">
+  <p:cSld>
+    <p:spTree>
+      <p:nvGrpSpPr>
+        <p:cNvPr id="1" name=""/>
+        <p:cNvGrpSpPr/>
+        <p:nvPr/>
+      </p:nvGrpSpPr>
+      <p:grpSpPr>
+        <a:xfrm>
+          <a:off x="0" y="0"/>
+          <a:ext cx="0" cy="0"/>
+          <a:chOff x="0" y="0"/>
+          <a:chExt cx="0" cy="0"/>
+        </a:xfrm>
+      </p:grpSpPr>
+      <p:sp>
+        <p:nvSpPr>
+          <p:cNvPr id="2" name="Slide Image Placeholder 1"/>
+          <p:cNvSpPr>
+            <a:spLocks noGrp="1" noRot="1" noChangeAspect="1"/>
+          </p:cNvSpPr>
+          <p:nvPr>
+            <p:ph type="sldImg"/>
+          </p:nvPr>
+        </p:nvSpPr>
+        <p:spPr/>
+      </p:sp>
+      <p:sp>
+        <p:nvSpPr>
+          <p:cNvPr id="3" name="Notes Placeholder 2"/>
+          <p:cNvSpPr>
+            <a:spLocks noGrp="1"/>
+          </p:cNvSpPr>
+          <p:nvPr>
+            <p:ph type="body" idx="1"/>
+          </p:nvPr>
+        </p:nvSpPr>
+        <p:spPr/>
+        <p:txBody>
+          <a:bodyPr/>
+          <a:lstStyle/>
+          <a:p>
+            <a:r>
+              <a:rPr lang="en-US" dirty="0"/>
+              <a:t/>
+            </a:r>
+            <a:endParaRPr lang="en-US" dirty="0"/>
+          </a:p>
+        </p:txBody>
+      </p:sp>
+      <p:sp>
+        <p:nvSpPr>
+          <p:cNvPr id="4" name="Slide Number Placeholder 3"/>
+          <p:cNvSpPr>
+            <a:spLocks noGrp="1"/>
+          </p:cNvSpPr>
+          <p:nvPr>
+            <p:ph type="sldNum" sz="quarter" idx="10"/>
+          </p:nvPr>
+        </p:nvSpPr>
+        <p:spPr/>
+        <p:txBody>
+          <a:bodyPr/>
+          <a:lstStyle/>
+          <a:p>
+            <a:fld id="{F7021451-1387-4CA6-816F-3879F97B5CBC}" type="slidenum">
+              <a:rPr lang="en-US"/>
+              <a:t>9</a:t>
             </a:fld>
             <a:endParaRPr lang="en-US"/>
           </a:p>
@@ -1900,7 +1990,7 @@
                   <a:schemeClr val="accent5"/>
                 </a:solidFill>
               </a:rPr>
-              <a:t>An open-source, map-first way to teach the geography of India</a:t>
+              <a:t>Helping students master map work for their geography exams</a:t>
             </a:r>
             <a:endParaRPr lang="en-US" sz="1800" dirty="0"/>
           </a:p>
@@ -1987,7 +2077,7 @@
                   <a:schemeClr val="tx1"/>
                 </a:solidFill>
               </a:rPr>
-              <a:t>Geography sticks when it is learned on a map</a:t>
+              <a:t>Map work is where students get stuck</a:t>
             </a:r>
             <a:endParaRPr lang="en-US" sz="2800" dirty="0"/>
           </a:p>
@@ -2001,8 +2091,8 @@
         </p:nvSpPr>
         <p:spPr>
           <a:xfrm>
-            <a:off x="457200" y="1097280"/>
-            <a:ext cx="8229600" cy="731520"/>
+            <a:off x="457200" y="1051560"/>
+            <a:ext cx="8229600" cy="457200"/>
           </a:xfrm>
           <a:prstGeom prst="rect">
             <a:avLst/>
@@ -2023,7 +2113,7 @@
                   <a:schemeClr val="tx2"/>
                 </a:solidFill>
               </a:rPr>
-              <a:t>TerraTeach puts India's river systems on an interactive map. Students explore, draw and label, then test themselves, while teachers see their work and talk to them live.</a:t>
+              <a:t>Map questions carry easy marks in geography exams, but students struggled to practise them well.</a:t>
             </a:r>
             <a:endParaRPr lang="en-US" sz="1600" dirty="0"/>
           </a:p>
@@ -2031,18 +2121,18 @@
       </p:sp>
       <p:sp>
         <p:nvSpPr>
-          <p:cNvPr id="4" name="Stat card"/>
+          <p:cNvPr id="4" name="Hard to reach the teacher"/>
           <p:cNvSpPr/>
           <p:nvPr/>
         </p:nvSpPr>
         <p:spPr>
           <a:xfrm>
-            <a:off x="457200" y="2148840"/>
-            <a:ext cx="2560320" cy="2286000"/>
+            <a:off x="457200" y="1783080"/>
+            <a:ext cx="2560320" cy="2651760"/>
           </a:xfrm>
           <a:prstGeom prst="roundRect">
             <a:avLst>
-              <a:gd name="adj" fmla="val 4800"/>
+              <a:gd name="adj" fmla="val 4286"/>
             </a:avLst>
           </a:prstGeom>
           <a:solidFill>
@@ -2053,42 +2143,23 @@
       </p:sp>
       <p:sp>
         <p:nvSpPr>
-          <p:cNvPr id="5" name="Text 3"/>
-          <p:cNvSpPr txBox="1"/>
-          <p:nvPr/>
-        </p:nvSpPr>
-        <p:spPr>
-          <a:xfrm>
-            <a:off x="731520" y="2331720"/>
-            <a:ext cx="2011680" cy="1005840"/>
-          </a:xfrm>
-          <a:prstGeom prst="rect">
-            <a:avLst/>
-          </a:prstGeom>
-          <a:noFill/>
-          <a:ln/>
-        </p:spPr>
-        <p:txBody>
-          <a:bodyPr wrap="square" lIns="0" tIns="0" rIns="0" bIns="0" rtlCol="0" anchor="ctr"/>
-          <a:lstStyle/>
-          <a:p>
-            <a:pPr indent="0" marL="0">
-              <a:buNone/>
-            </a:pPr>
-            <a:r>
-              <a:rPr lang="en-US" sz="6000" b="1" dirty="0">
-                <a:solidFill>
-                  <a:schemeClr val="accent2"/>
-                </a:solidFill>
-                <a:latin typeface="Cambria" pitchFamily="34" charset="0"/>
-                <a:ea typeface="Cambria" pitchFamily="34" charset="-122"/>
-                <a:cs typeface="Cambria" pitchFamily="34" charset="-120"/>
-              </a:rPr>
-              <a:t>20</a:t>
-            </a:r>
-            <a:endParaRPr lang="en-US" sz="6000" dirty="0"/>
-          </a:p>
-        </p:txBody>
+          <p:cNvPr id="5" name="Marker"/>
+          <p:cNvSpPr/>
+          <p:nvPr/>
+        </p:nvSpPr>
+        <p:spPr>
+          <a:xfrm>
+            <a:off x="731520" y="2011680"/>
+            <a:ext cx="457200" cy="457200"/>
+          </a:xfrm>
+          <a:prstGeom prst="ellipse">
+            <a:avLst/>
+          </a:prstGeom>
+          <a:solidFill>
+            <a:schemeClr val="accent1"/>
+          </a:solidFill>
+          <a:ln/>
+        </p:spPr>
       </p:sp>
       <p:sp>
         <p:nvSpPr>
@@ -2098,8 +2169,8 @@
         </p:nvSpPr>
         <p:spPr>
           <a:xfrm>
-            <a:off x="731520" y="3383280"/>
-            <a:ext cx="2057400" cy="868680"/>
+            <a:off x="731520" y="2011680"/>
+            <a:ext cx="457200" cy="457200"/>
           </a:xfrm>
           <a:prstGeom prst="rect">
             <a:avLst/>
@@ -2108,10 +2179,66 @@
           <a:ln/>
         </p:spPr>
         <p:txBody>
+          <a:bodyPr wrap="square" lIns="0" tIns="0" rIns="0" bIns="0" rtlCol="0" anchor="ctr"/>
+          <a:lstStyle/>
+          <a:p>
+            <a:pPr algn="ctr" indent="0" marL="0">
+              <a:buNone/>
+            </a:pPr>
+            <a:r>
+              <a:rPr lang="en-US" sz="1600" b="1" dirty="0">
+                <a:solidFill>
+                  <a:schemeClr val="bg1"/>
+                </a:solidFill>
+              </a:rPr>
+              <a:t>1</a:t>
+            </a:r>
+            <a:endParaRPr lang="en-US" sz="1600" dirty="0"/>
+          </a:p>
+        </p:txBody>
+      </p:sp>
+      <p:sp>
+        <p:nvSpPr>
+          <p:cNvPr id="7" name="Text 5"/>
+          <p:cNvSpPr txBox="1"/>
+          <p:nvPr/>
+        </p:nvSpPr>
+        <p:spPr>
+          <a:xfrm>
+            <a:off x="731520" y="2651760"/>
+            <a:ext cx="2057400" cy="1645920"/>
+          </a:xfrm>
+          <a:prstGeom prst="rect">
+            <a:avLst/>
+          </a:prstGeom>
+          <a:noFill/>
+          <a:ln/>
+        </p:spPr>
+        <p:txBody>
           <a:bodyPr wrap="square" lIns="0" tIns="0" rIns="0" bIns="0" rtlCol="0" anchor="t"/>
           <a:lstStyle/>
           <a:p>
             <a:pPr indent="0" marL="0">
+              <a:spcAft>
+                <a:spcPts val="600"/>
+              </a:spcAft>
+              <a:buNone/>
+            </a:pPr>
+            <a:r>
+              <a:rPr lang="en-US" sz="1700" b="1" dirty="0">
+                <a:solidFill>
+                  <a:schemeClr val="tx1"/>
+                </a:solidFill>
+              </a:rPr>
+              <a:t>Hard to reach the teacher</a:t>
+            </a:r>
+            <a:endParaRPr lang="en-US" sz="1700" dirty="0"/>
+          </a:p>
+          <a:p>
+            <a:pPr indent="0" marL="0">
+              <a:spcAft>
+                <a:spcPts val="600"/>
+              </a:spcAft>
               <a:buNone/>
             </a:pPr>
             <a:r>
@@ -2120,26 +2247,26 @@
                   <a:schemeClr val="tx2"/>
                 </a:solidFill>
               </a:rPr>
-              <a:t>rivers traced on the map, from the Indus to the Kaveri</a:t>
-            </a:r>
-            <a:endParaRPr lang="en-US" sz="1400" dirty="0"/>
-          </a:p>
-        </p:txBody>
-      </p:sp>
-      <p:sp>
-        <p:nvSpPr>
-          <p:cNvPr id="7" name="Stat card"/>
+              <a:t>In online classes, students couldn't easily show their map to a teacher or ask if it was right.</a:t>
+            </a:r>
+            <a:endParaRPr lang="en-US" sz="1700" dirty="0"/>
+          </a:p>
+        </p:txBody>
+      </p:sp>
+      <p:sp>
+        <p:nvSpPr>
+          <p:cNvPr id="8" name="No clear right answer"/>
           <p:cNvSpPr/>
           <p:nvPr/>
         </p:nvSpPr>
         <p:spPr>
           <a:xfrm>
-            <a:off x="3291840" y="2148840"/>
-            <a:ext cx="2560320" cy="2286000"/>
+            <a:off x="3291840" y="1783080"/>
+            <a:ext cx="2560320" cy="2651760"/>
           </a:xfrm>
           <a:prstGeom prst="roundRect">
             <a:avLst>
-              <a:gd name="adj" fmla="val 4800"/>
+              <a:gd name="adj" fmla="val 4286"/>
             </a:avLst>
           </a:prstGeom>
           <a:solidFill>
@@ -2150,14 +2277,34 @@
       </p:sp>
       <p:sp>
         <p:nvSpPr>
-          <p:cNvPr id="8" name="Text 6"/>
+          <p:cNvPr id="9" name="Marker"/>
+          <p:cNvSpPr/>
+          <p:nvPr/>
+        </p:nvSpPr>
+        <p:spPr>
+          <a:xfrm>
+            <a:off x="3566160" y="2011680"/>
+            <a:ext cx="457200" cy="457200"/>
+          </a:xfrm>
+          <a:prstGeom prst="ellipse">
+            <a:avLst/>
+          </a:prstGeom>
+          <a:solidFill>
+            <a:schemeClr val="accent1"/>
+          </a:solidFill>
+          <a:ln/>
+        </p:spPr>
+      </p:sp>
+      <p:sp>
+        <p:nvSpPr>
+          <p:cNvPr id="10" name="Text 8"/>
           <p:cNvSpPr txBox="1"/>
           <p:nvPr/>
         </p:nvSpPr>
         <p:spPr>
           <a:xfrm>
-            <a:off x="3566160" y="2331720"/>
-            <a:ext cx="2011680" cy="1005840"/>
+            <a:off x="3566160" y="2011680"/>
+            <a:ext cx="457200" cy="457200"/>
           </a:xfrm>
           <a:prstGeom prst="rect">
             <a:avLst/>
@@ -2169,46 +2316,63 @@
           <a:bodyPr wrap="square" lIns="0" tIns="0" rIns="0" bIns="0" rtlCol="0" anchor="ctr"/>
           <a:lstStyle/>
           <a:p>
+            <a:pPr algn="ctr" indent="0" marL="0">
+              <a:buNone/>
+            </a:pPr>
+            <a:r>
+              <a:rPr lang="en-US" sz="1600" b="1" dirty="0">
+                <a:solidFill>
+                  <a:schemeClr val="bg1"/>
+                </a:solidFill>
+              </a:rPr>
+              <a:t>2</a:t>
+            </a:r>
+            <a:endParaRPr lang="en-US" sz="1600" dirty="0"/>
+          </a:p>
+        </p:txBody>
+      </p:sp>
+      <p:sp>
+        <p:nvSpPr>
+          <p:cNvPr id="11" name="Text 9"/>
+          <p:cNvSpPr txBox="1"/>
+          <p:nvPr/>
+        </p:nvSpPr>
+        <p:spPr>
+          <a:xfrm>
+            <a:off x="3566160" y="2651760"/>
+            <a:ext cx="2057400" cy="1645920"/>
+          </a:xfrm>
+          <a:prstGeom prst="rect">
+            <a:avLst/>
+          </a:prstGeom>
+          <a:noFill/>
+          <a:ln/>
+        </p:spPr>
+        <p:txBody>
+          <a:bodyPr wrap="square" lIns="0" tIns="0" rIns="0" bIns="0" rtlCol="0" anchor="t"/>
+          <a:lstStyle/>
+          <a:p>
             <a:pPr indent="0" marL="0">
-              <a:buNone/>
-            </a:pPr>
-            <a:r>
-              <a:rPr lang="en-US" sz="6000" b="1" dirty="0">
-                <a:solidFill>
-                  <a:schemeClr val="accent1"/>
-                </a:solidFill>
-                <a:latin typeface="Cambria" pitchFamily="34" charset="0"/>
-                <a:ea typeface="Cambria" pitchFamily="34" charset="-122"/>
-                <a:cs typeface="Cambria" pitchFamily="34" charset="-120"/>
-              </a:rPr>
-              <a:t>4</a:t>
-            </a:r>
-            <a:endParaRPr lang="en-US" sz="6000" dirty="0"/>
-          </a:p>
-        </p:txBody>
-      </p:sp>
-      <p:sp>
-        <p:nvSpPr>
-          <p:cNvPr id="9" name="Text 7"/>
-          <p:cNvSpPr txBox="1"/>
-          <p:nvPr/>
-        </p:nvSpPr>
-        <p:spPr>
-          <a:xfrm>
-            <a:off x="3566160" y="3383280"/>
-            <a:ext cx="2057400" cy="868680"/>
-          </a:xfrm>
-          <a:prstGeom prst="rect">
-            <a:avLst/>
-          </a:prstGeom>
-          <a:noFill/>
-          <a:ln/>
-        </p:spPr>
-        <p:txBody>
-          <a:bodyPr wrap="square" lIns="0" tIns="0" rIns="0" bIns="0" rtlCol="0" anchor="t"/>
-          <a:lstStyle/>
+              <a:spcAft>
+                <a:spcPts val="600"/>
+              </a:spcAft>
+              <a:buNone/>
+            </a:pPr>
+            <a:r>
+              <a:rPr lang="en-US" sz="1700" b="1" dirty="0">
+                <a:solidFill>
+                  <a:schemeClr val="tx1"/>
+                </a:solidFill>
+              </a:rPr>
+              <a:t>No clear right answer</a:t>
+            </a:r>
+            <a:endParaRPr lang="en-US" sz="1700" dirty="0"/>
+          </a:p>
           <a:p>
             <a:pPr indent="0" marL="0">
+              <a:spcAft>
+                <a:spcPts val="600"/>
+              </a:spcAft>
               <a:buNone/>
             </a:pPr>
             <a:r>
@@ -2217,26 +2381,26 @@
                   <a:schemeClr val="tx2"/>
                 </a:solidFill>
               </a:rPr>
-              <a:t>views: Explore, Annotate, Test Yourself and Teacher Dashboard</a:t>
-            </a:r>
-            <a:endParaRPr lang="en-US" sz="1400" dirty="0"/>
-          </a:p>
-        </p:txBody>
-      </p:sp>
-      <p:sp>
-        <p:nvSpPr>
-          <p:cNvPr id="10" name="Stat card"/>
+              <a:t>Atlases and textbooks draw rivers differently, so students never knew exactly what the examiner expects.</a:t>
+            </a:r>
+            <a:endParaRPr lang="en-US" sz="1700" dirty="0"/>
+          </a:p>
+        </p:txBody>
+      </p:sp>
+      <p:sp>
+        <p:nvSpPr>
+          <p:cNvPr id="12" name="Practising alone"/>
           <p:cNvSpPr/>
           <p:nvPr/>
         </p:nvSpPr>
         <p:spPr>
           <a:xfrm>
-            <a:off x="6126480" y="2148840"/>
-            <a:ext cx="2560320" cy="2286000"/>
+            <a:off x="6126480" y="1783080"/>
+            <a:ext cx="2560320" cy="2651760"/>
           </a:xfrm>
           <a:prstGeom prst="roundRect">
             <a:avLst>
-              <a:gd name="adj" fmla="val 4800"/>
+              <a:gd name="adj" fmla="val 4286"/>
             </a:avLst>
           </a:prstGeom>
           <a:solidFill>
@@ -2247,14 +2411,34 @@
       </p:sp>
       <p:sp>
         <p:nvSpPr>
-          <p:cNvPr id="11" name="Text 9"/>
+          <p:cNvPr id="13" name="Marker"/>
+          <p:cNvSpPr/>
+          <p:nvPr/>
+        </p:nvSpPr>
+        <p:spPr>
+          <a:xfrm>
+            <a:off x="6400800" y="2011680"/>
+            <a:ext cx="457200" cy="457200"/>
+          </a:xfrm>
+          <a:prstGeom prst="ellipse">
+            <a:avLst/>
+          </a:prstGeom>
+          <a:solidFill>
+            <a:schemeClr val="accent1"/>
+          </a:solidFill>
+          <a:ln/>
+        </p:spPr>
+      </p:sp>
+      <p:sp>
+        <p:nvSpPr>
+          <p:cNvPr id="14" name="Text 12"/>
           <p:cNvSpPr txBox="1"/>
           <p:nvPr/>
         </p:nvSpPr>
         <p:spPr>
           <a:xfrm>
-            <a:off x="6400800" y="2331720"/>
-            <a:ext cx="2011680" cy="1005840"/>
+            <a:off x="6400800" y="2011680"/>
+            <a:ext cx="457200" cy="457200"/>
           </a:xfrm>
           <a:prstGeom prst="rect">
             <a:avLst/>
@@ -2266,46 +2450,63 @@
           <a:bodyPr wrap="square" lIns="0" tIns="0" rIns="0" bIns="0" rtlCol="0" anchor="ctr"/>
           <a:lstStyle/>
           <a:p>
+            <a:pPr algn="ctr" indent="0" marL="0">
+              <a:buNone/>
+            </a:pPr>
+            <a:r>
+              <a:rPr lang="en-US" sz="1600" b="1" dirty="0">
+                <a:solidFill>
+                  <a:schemeClr val="bg1"/>
+                </a:solidFill>
+              </a:rPr>
+              <a:t>3</a:t>
+            </a:r>
+            <a:endParaRPr lang="en-US" sz="1600" dirty="0"/>
+          </a:p>
+        </p:txBody>
+      </p:sp>
+      <p:sp>
+        <p:nvSpPr>
+          <p:cNvPr id="15" name="Text 13"/>
+          <p:cNvSpPr txBox="1"/>
+          <p:nvPr/>
+        </p:nvSpPr>
+        <p:spPr>
+          <a:xfrm>
+            <a:off x="6400800" y="2651760"/>
+            <a:ext cx="2057400" cy="1645920"/>
+          </a:xfrm>
+          <a:prstGeom prst="rect">
+            <a:avLst/>
+          </a:prstGeom>
+          <a:noFill/>
+          <a:ln/>
+        </p:spPr>
+        <p:txBody>
+          <a:bodyPr wrap="square" lIns="0" tIns="0" rIns="0" bIns="0" rtlCol="0" anchor="t"/>
+          <a:lstStyle/>
+          <a:p>
             <a:pPr indent="0" marL="0">
-              <a:buNone/>
-            </a:pPr>
-            <a:r>
-              <a:rPr lang="en-US" sz="6000" b="1" dirty="0">
-                <a:solidFill>
-                  <a:schemeClr val="accent1"/>
-                </a:solidFill>
-                <a:latin typeface="Cambria" pitchFamily="34" charset="0"/>
-                <a:ea typeface="Cambria" pitchFamily="34" charset="-122"/>
-                <a:cs typeface="Cambria" pitchFamily="34" charset="-120"/>
-              </a:rPr>
-              <a:t>1</a:t>
-            </a:r>
-            <a:endParaRPr lang="en-US" sz="6000" dirty="0"/>
-          </a:p>
-        </p:txBody>
-      </p:sp>
-      <p:sp>
-        <p:nvSpPr>
-          <p:cNvPr id="12" name="Text 10"/>
-          <p:cNvSpPr txBox="1"/>
-          <p:nvPr/>
-        </p:nvSpPr>
-        <p:spPr>
-          <a:xfrm>
-            <a:off x="6400800" y="3383280"/>
-            <a:ext cx="2057400" cy="868680"/>
-          </a:xfrm>
-          <a:prstGeom prst="rect">
-            <a:avLst/>
-          </a:prstGeom>
-          <a:noFill/>
-          <a:ln/>
-        </p:spPr>
-        <p:txBody>
-          <a:bodyPr wrap="square" lIns="0" tIns="0" rIns="0" bIns="0" rtlCol="0" anchor="t"/>
-          <a:lstStyle/>
+              <a:spcAft>
+                <a:spcPts val="600"/>
+              </a:spcAft>
+              <a:buNone/>
+            </a:pPr>
+            <a:r>
+              <a:rPr lang="en-US" sz="1700" b="1" dirty="0">
+                <a:solidFill>
+                  <a:schemeClr val="tx1"/>
+                </a:solidFill>
+              </a:rPr>
+              <a:t>Practising alone</a:t>
+            </a:r>
+            <a:endParaRPr lang="en-US" sz="1700" dirty="0"/>
+          </a:p>
           <a:p>
             <a:pPr indent="0" marL="0">
+              <a:spcAft>
+                <a:spcPts val="600"/>
+              </a:spcAft>
               <a:buNone/>
             </a:pPr>
             <a:r>
@@ -2314,9 +2515,9 @@
                   <a:schemeClr val="tx2"/>
                 </a:solidFill>
               </a:rPr>
-              <a:t>small Node/Express server, with no build step</a:t>
-            </a:r>
-            <a:endParaRPr lang="en-US" sz="1400" dirty="0"/>
+              <a:t>Students had no way to check their own map, so mistakes only showed up in the exam.</a:t>
+            </a:r>
+            <a:endParaRPr lang="en-US" sz="1700" dirty="0"/>
           </a:p>
         </p:txBody>
       </p:sp>
@@ -2422,15 +2623,369 @@
                   <a:schemeClr val="tx1"/>
                 </a:solidFill>
               </a:rPr>
-              <a:t>Explore Rivers: one river at a time</a:t>
+              <a:t>One place to learn, practise and get feedback</a:t>
             </a:r>
             <a:endParaRPr lang="en-US" sz="2800" dirty="0"/>
+          </a:p>
+        </p:txBody>
+      </p:sp>
+      <p:sp>
+        <p:nvSpPr>
+          <p:cNvPr id="3" name="Text 1"/>
+          <p:cNvSpPr txBox="1"/>
+          <p:nvPr/>
+        </p:nvSpPr>
+        <p:spPr>
+          <a:xfrm>
+            <a:off x="457200" y="1097280"/>
+            <a:ext cx="4572000" cy="640080"/>
+          </a:xfrm>
+          <a:prstGeom prst="rect">
+            <a:avLst/>
+          </a:prstGeom>
+          <a:noFill/>
+          <a:ln/>
+        </p:spPr>
+        <p:txBody>
+          <a:bodyPr wrap="square" lIns="0" tIns="0" rIns="0" bIns="0" rtlCol="0" anchor="ctr"/>
+          <a:lstStyle/>
+          <a:p>
+            <a:pPr indent="0" marL="0">
+              <a:buNone/>
+            </a:pPr>
+            <a:r>
+              <a:rPr lang="en-US" sz="1600" dirty="0">
+                <a:solidFill>
+                  <a:schemeClr val="tx2"/>
+                </a:solidFill>
+              </a:rPr>
+              <a:t>TerraTeach turns a blank map of India into a classroom that students can use from home.</a:t>
+            </a:r>
+            <a:endParaRPr lang="en-US" sz="1600" dirty="0"/>
+          </a:p>
+        </p:txBody>
+      </p:sp>
+      <p:sp>
+        <p:nvSpPr>
+          <p:cNvPr id="4" name="Step 1"/>
+          <p:cNvSpPr/>
+          <p:nvPr/>
+        </p:nvSpPr>
+        <p:spPr>
+          <a:xfrm>
+            <a:off x="457200" y="1920240"/>
+            <a:ext cx="384048" cy="384048"/>
+          </a:xfrm>
+          <a:prstGeom prst="ellipse">
+            <a:avLst/>
+          </a:prstGeom>
+          <a:solidFill>
+            <a:schemeClr val="accent1"/>
+          </a:solidFill>
+          <a:ln/>
+        </p:spPr>
+      </p:sp>
+      <p:sp>
+        <p:nvSpPr>
+          <p:cNvPr id="5" name="Text 3"/>
+          <p:cNvSpPr txBox="1"/>
+          <p:nvPr/>
+        </p:nvSpPr>
+        <p:spPr>
+          <a:xfrm>
+            <a:off x="457200" y="1920240"/>
+            <a:ext cx="384048" cy="384048"/>
+          </a:xfrm>
+          <a:prstGeom prst="rect">
+            <a:avLst/>
+          </a:prstGeom>
+          <a:noFill/>
+          <a:ln/>
+        </p:spPr>
+        <p:txBody>
+          <a:bodyPr wrap="square" lIns="0" tIns="0" rIns="0" bIns="0" rtlCol="0" anchor="ctr"/>
+          <a:lstStyle/>
+          <a:p>
+            <a:pPr algn="ctr" indent="0" marL="0">
+              <a:buNone/>
+            </a:pPr>
+            <a:r>
+              <a:rPr lang="en-US" sz="1400" b="1" dirty="0">
+                <a:solidFill>
+                  <a:schemeClr val="bg1"/>
+                </a:solidFill>
+              </a:rPr>
+              <a:t>1</a:t>
+            </a:r>
+            <a:endParaRPr lang="en-US" sz="1400" dirty="0"/>
+          </a:p>
+        </p:txBody>
+      </p:sp>
+      <p:sp>
+        <p:nvSpPr>
+          <p:cNvPr id="6" name="Text 4"/>
+          <p:cNvSpPr txBox="1"/>
+          <p:nvPr/>
+        </p:nvSpPr>
+        <p:spPr>
+          <a:xfrm>
+            <a:off x="1005840" y="1874520"/>
+            <a:ext cx="4023360" cy="868680"/>
+          </a:xfrm>
+          <a:prstGeom prst="rect">
+            <a:avLst/>
+          </a:prstGeom>
+          <a:noFill/>
+          <a:ln/>
+        </p:spPr>
+        <p:txBody>
+          <a:bodyPr wrap="square" lIns="0" tIns="0" rIns="0" bIns="0" rtlCol="0" anchor="t"/>
+          <a:lstStyle/>
+          <a:p>
+            <a:pPr indent="0" marL="0">
+              <a:buNone/>
+            </a:pPr>
+            <a:r>
+              <a:rPr lang="en-US" sz="1600" b="1" dirty="0">
+                <a:solidFill>
+                  <a:schemeClr val="tx1"/>
+                </a:solidFill>
+              </a:rPr>
+              <a:t>Learn from answer maps</a:t>
+            </a:r>
+            <a:endParaRPr lang="en-US" sz="1600" dirty="0"/>
+          </a:p>
+          <a:p>
+            <a:pPr indent="0" marL="0">
+              <a:buNone/>
+            </a:pPr>
+            <a:r>
+              <a:rPr lang="en-US" sz="1400" dirty="0">
+                <a:solidFill>
+                  <a:schemeClr val="tx2"/>
+                </a:solidFill>
+              </a:rPr>
+              <a:t>Every river is traced exactly as the exam expects it</a:t>
+            </a:r>
+            <a:endParaRPr lang="en-US" sz="1600" dirty="0"/>
+          </a:p>
+        </p:txBody>
+      </p:sp>
+      <p:sp>
+        <p:nvSpPr>
+          <p:cNvPr id="7" name="Step 2"/>
+          <p:cNvSpPr/>
+          <p:nvPr/>
+        </p:nvSpPr>
+        <p:spPr>
+          <a:xfrm>
+            <a:off x="457200" y="2880360"/>
+            <a:ext cx="384048" cy="384048"/>
+          </a:xfrm>
+          <a:prstGeom prst="ellipse">
+            <a:avLst/>
+          </a:prstGeom>
+          <a:solidFill>
+            <a:schemeClr val="accent1"/>
+          </a:solidFill>
+          <a:ln/>
+        </p:spPr>
+      </p:sp>
+      <p:sp>
+        <p:nvSpPr>
+          <p:cNvPr id="8" name="Text 6"/>
+          <p:cNvSpPr txBox="1"/>
+          <p:nvPr/>
+        </p:nvSpPr>
+        <p:spPr>
+          <a:xfrm>
+            <a:off x="457200" y="2880360"/>
+            <a:ext cx="384048" cy="384048"/>
+          </a:xfrm>
+          <a:prstGeom prst="rect">
+            <a:avLst/>
+          </a:prstGeom>
+          <a:noFill/>
+          <a:ln/>
+        </p:spPr>
+        <p:txBody>
+          <a:bodyPr wrap="square" lIns="0" tIns="0" rIns="0" bIns="0" rtlCol="0" anchor="ctr"/>
+          <a:lstStyle/>
+          <a:p>
+            <a:pPr algn="ctr" indent="0" marL="0">
+              <a:buNone/>
+            </a:pPr>
+            <a:r>
+              <a:rPr lang="en-US" sz="1400" b="1" dirty="0">
+                <a:solidFill>
+                  <a:schemeClr val="bg1"/>
+                </a:solidFill>
+              </a:rPr>
+              <a:t>2</a:t>
+            </a:r>
+            <a:endParaRPr lang="en-US" sz="1400" dirty="0"/>
+          </a:p>
+        </p:txBody>
+      </p:sp>
+      <p:sp>
+        <p:nvSpPr>
+          <p:cNvPr id="9" name="Text 7"/>
+          <p:cNvSpPr txBox="1"/>
+          <p:nvPr/>
+        </p:nvSpPr>
+        <p:spPr>
+          <a:xfrm>
+            <a:off x="1005840" y="2834640"/>
+            <a:ext cx="4023360" cy="868680"/>
+          </a:xfrm>
+          <a:prstGeom prst="rect">
+            <a:avLst/>
+          </a:prstGeom>
+          <a:noFill/>
+          <a:ln/>
+        </p:spPr>
+        <p:txBody>
+          <a:bodyPr wrap="square" lIns="0" tIns="0" rIns="0" bIns="0" rtlCol="0" anchor="t"/>
+          <a:lstStyle/>
+          <a:p>
+            <a:pPr indent="0" marL="0">
+              <a:buNone/>
+            </a:pPr>
+            <a:r>
+              <a:rPr lang="en-US" sz="1600" b="1" dirty="0">
+                <a:solidFill>
+                  <a:schemeClr val="tx1"/>
+                </a:solidFill>
+              </a:rPr>
+              <a:t>Practise and check</a:t>
+            </a:r>
+            <a:endParaRPr lang="en-US" sz="1600" dirty="0"/>
+          </a:p>
+          <a:p>
+            <a:pPr indent="0" marL="0">
+              <a:buNone/>
+            </a:pPr>
+            <a:r>
+              <a:rPr lang="en-US" sz="1400" dirty="0">
+                <a:solidFill>
+                  <a:schemeClr val="tx2"/>
+                </a:solidFill>
+              </a:rPr>
+              <a:t>Draw on a blank map, then compare with the right answer</a:t>
+            </a:r>
+            <a:endParaRPr lang="en-US" sz="1600" dirty="0"/>
+          </a:p>
+        </p:txBody>
+      </p:sp>
+      <p:sp>
+        <p:nvSpPr>
+          <p:cNvPr id="10" name="Step 3"/>
+          <p:cNvSpPr/>
+          <p:nvPr/>
+        </p:nvSpPr>
+        <p:spPr>
+          <a:xfrm>
+            <a:off x="457200" y="3840480"/>
+            <a:ext cx="384048" cy="384048"/>
+          </a:xfrm>
+          <a:prstGeom prst="ellipse">
+            <a:avLst/>
+          </a:prstGeom>
+          <a:solidFill>
+            <a:schemeClr val="accent1"/>
+          </a:solidFill>
+          <a:ln/>
+        </p:spPr>
+      </p:sp>
+      <p:sp>
+        <p:nvSpPr>
+          <p:cNvPr id="11" name="Text 9"/>
+          <p:cNvSpPr txBox="1"/>
+          <p:nvPr/>
+        </p:nvSpPr>
+        <p:spPr>
+          <a:xfrm>
+            <a:off x="457200" y="3840480"/>
+            <a:ext cx="384048" cy="384048"/>
+          </a:xfrm>
+          <a:prstGeom prst="rect">
+            <a:avLst/>
+          </a:prstGeom>
+          <a:noFill/>
+          <a:ln/>
+        </p:spPr>
+        <p:txBody>
+          <a:bodyPr wrap="square" lIns="0" tIns="0" rIns="0" bIns="0" rtlCol="0" anchor="ctr"/>
+          <a:lstStyle/>
+          <a:p>
+            <a:pPr algn="ctr" indent="0" marL="0">
+              <a:buNone/>
+            </a:pPr>
+            <a:r>
+              <a:rPr lang="en-US" sz="1400" b="1" dirty="0">
+                <a:solidFill>
+                  <a:schemeClr val="bg1"/>
+                </a:solidFill>
+              </a:rPr>
+              <a:t>3</a:t>
+            </a:r>
+            <a:endParaRPr lang="en-US" sz="1400" dirty="0"/>
+          </a:p>
+        </p:txBody>
+      </p:sp>
+      <p:sp>
+        <p:nvSpPr>
+          <p:cNvPr id="12" name="Text 10"/>
+          <p:cNvSpPr txBox="1"/>
+          <p:nvPr/>
+        </p:nvSpPr>
+        <p:spPr>
+          <a:xfrm>
+            <a:off x="1005840" y="3794760"/>
+            <a:ext cx="4023360" cy="868680"/>
+          </a:xfrm>
+          <a:prstGeom prst="rect">
+            <a:avLst/>
+          </a:prstGeom>
+          <a:noFill/>
+          <a:ln/>
+        </p:spPr>
+        <p:txBody>
+          <a:bodyPr wrap="square" lIns="0" tIns="0" rIns="0" bIns="0" rtlCol="0" anchor="t"/>
+          <a:lstStyle/>
+          <a:p>
+            <a:pPr indent="0" marL="0">
+              <a:buNone/>
+            </a:pPr>
+            <a:r>
+              <a:rPr lang="en-US" sz="1600" b="1" dirty="0">
+                <a:solidFill>
+                  <a:schemeClr val="tx1"/>
+                </a:solidFill>
+              </a:rPr>
+              <a:t>Ask the teacher</a:t>
+            </a:r>
+            <a:endParaRPr lang="en-US" sz="1600" dirty="0"/>
+          </a:p>
+          <a:p>
+            <a:pPr indent="0" marL="0">
+              <a:buNone/>
+            </a:pPr>
+            <a:r>
+              <a:rPr lang="en-US" sz="1400" dirty="0">
+                <a:solidFill>
+                  <a:schemeClr val="tx2"/>
+                </a:solidFill>
+              </a:rPr>
+              <a:t>Send your map in and get feedback, even online</a:t>
+            </a:r>
+            <a:endParaRPr lang="en-US" sz="1600" dirty="0"/>
           </a:p>
         </p:txBody>
       </p:sp>
       <p:pic>
         <p:nvPicPr>
-          <p:cNvPr id="3" name="Screenshot" descr="rivers.jpg">    </p:cNvPr>
+          <p:cNvPr id="13" name="River map" descr="allrivers.jpg">    </p:cNvPr>
           <p:cNvPicPr>
             <a:picLocks noChangeAspect="1"/>
           </p:cNvPicPr>
@@ -2444,339 +2999,14 @@
         </p:blipFill>
         <p:spPr>
           <a:xfrm>
-            <a:off x="457200" y="1234440"/>
-            <a:ext cx="4937760" cy="2777490"/>
-          </a:xfrm>
-          <a:prstGeom prst="rect">
-            <a:avLst/>
-          </a:prstGeom>
-          <a:effectLst>
-            <a:outerShdw sx="100000" sy="100000" kx="0" ky="0" algn="bl" rotWithShape="0" blurRad="101600" dist="25400" dir="5400000">
-              <a:srgbClr val="000000">
-                <a:alpha val="18000"/>
-              </a:srgbClr>
-            </a:outerShdw>
-          </a:effectLst>
+            <a:off x="5440680" y="1097280"/>
+            <a:ext cx="3337560" cy="3749040"/>
+          </a:xfrm>
+          <a:prstGeom prst="rect">
+            <a:avLst/>
+          </a:prstGeom>
         </p:spPr>
       </p:pic>
-      <p:sp>
-        <p:nvSpPr>
-          <p:cNvPr id="4" name="Step 1"/>
-          <p:cNvSpPr/>
-          <p:nvPr/>
-        </p:nvSpPr>
-        <p:spPr>
-          <a:xfrm>
-            <a:off x="5715000" y="1280160"/>
-            <a:ext cx="384048" cy="384048"/>
-          </a:xfrm>
-          <a:prstGeom prst="ellipse">
-            <a:avLst/>
-          </a:prstGeom>
-          <a:solidFill>
-            <a:schemeClr val="accent1"/>
-          </a:solidFill>
-          <a:ln/>
-        </p:spPr>
-      </p:sp>
-      <p:sp>
-        <p:nvSpPr>
-          <p:cNvPr id="5" name="Text 2"/>
-          <p:cNvSpPr txBox="1"/>
-          <p:nvPr/>
-        </p:nvSpPr>
-        <p:spPr>
-          <a:xfrm>
-            <a:off x="5715000" y="1280160"/>
-            <a:ext cx="384048" cy="384048"/>
-          </a:xfrm>
-          <a:prstGeom prst="rect">
-            <a:avLst/>
-          </a:prstGeom>
-          <a:noFill/>
-          <a:ln/>
-        </p:spPr>
-        <p:txBody>
-          <a:bodyPr wrap="square" lIns="0" tIns="0" rIns="0" bIns="0" rtlCol="0" anchor="ctr"/>
-          <a:lstStyle/>
-          <a:p>
-            <a:pPr algn="ctr" indent="0" marL="0">
-              <a:buNone/>
-            </a:pPr>
-            <a:r>
-              <a:rPr lang="en-US" sz="1400" b="1" dirty="0">
-                <a:solidFill>
-                  <a:schemeClr val="bg1"/>
-                </a:solidFill>
-              </a:rPr>
-              <a:t>1</a:t>
-            </a:r>
-            <a:endParaRPr lang="en-US" sz="1400" dirty="0"/>
-          </a:p>
-        </p:txBody>
-      </p:sp>
-      <p:sp>
-        <p:nvSpPr>
-          <p:cNvPr id="6" name="Text 3"/>
-          <p:cNvSpPr txBox="1"/>
-          <p:nvPr/>
-        </p:nvSpPr>
-        <p:spPr>
-          <a:xfrm>
-            <a:off x="6263640" y="1234440"/>
-            <a:ext cx="2468880" cy="868680"/>
-          </a:xfrm>
-          <a:prstGeom prst="rect">
-            <a:avLst/>
-          </a:prstGeom>
-          <a:noFill/>
-          <a:ln/>
-        </p:spPr>
-        <p:txBody>
-          <a:bodyPr wrap="square" lIns="0" tIns="0" rIns="0" bIns="0" rtlCol="0" anchor="t"/>
-          <a:lstStyle/>
-          <a:p>
-            <a:pPr indent="0" marL="0">
-              <a:buNone/>
-            </a:pPr>
-            <a:r>
-              <a:rPr lang="en-US" sz="1600" b="1" dirty="0">
-                <a:solidFill>
-                  <a:schemeClr val="tx1"/>
-                </a:solidFill>
-              </a:rPr>
-              <a:t>Show or hide each river</a:t>
-            </a:r>
-            <a:endParaRPr lang="en-US" sz="1600" dirty="0"/>
-          </a:p>
-          <a:p>
-            <a:pPr indent="0" marL="0">
-              <a:buNone/>
-            </a:pPr>
-            <a:r>
-              <a:rPr lang="en-US" sz="1400" dirty="0">
-                <a:solidFill>
-                  <a:schemeClr val="tx2"/>
-                </a:solidFill>
-              </a:rPr>
-              <a:t>20 hand-traced SVG paths, toggled on their own or all at once</a:t>
-            </a:r>
-            <a:endParaRPr lang="en-US" sz="1600" dirty="0"/>
-          </a:p>
-        </p:txBody>
-      </p:sp>
-      <p:sp>
-        <p:nvSpPr>
-          <p:cNvPr id="7" name="Step 2"/>
-          <p:cNvSpPr/>
-          <p:nvPr/>
-        </p:nvSpPr>
-        <p:spPr>
-          <a:xfrm>
-            <a:off x="5715000" y="2240280"/>
-            <a:ext cx="384048" cy="384048"/>
-          </a:xfrm>
-          <a:prstGeom prst="ellipse">
-            <a:avLst/>
-          </a:prstGeom>
-          <a:solidFill>
-            <a:schemeClr val="accent1"/>
-          </a:solidFill>
-          <a:ln/>
-        </p:spPr>
-      </p:sp>
-      <p:sp>
-        <p:nvSpPr>
-          <p:cNvPr id="8" name="Text 5"/>
-          <p:cNvSpPr txBox="1"/>
-          <p:nvPr/>
-        </p:nvSpPr>
-        <p:spPr>
-          <a:xfrm>
-            <a:off x="5715000" y="2240280"/>
-            <a:ext cx="384048" cy="384048"/>
-          </a:xfrm>
-          <a:prstGeom prst="rect">
-            <a:avLst/>
-          </a:prstGeom>
-          <a:noFill/>
-          <a:ln/>
-        </p:spPr>
-        <p:txBody>
-          <a:bodyPr wrap="square" lIns="0" tIns="0" rIns="0" bIns="0" rtlCol="0" anchor="ctr"/>
-          <a:lstStyle/>
-          <a:p>
-            <a:pPr algn="ctr" indent="0" marL="0">
-              <a:buNone/>
-            </a:pPr>
-            <a:r>
-              <a:rPr lang="en-US" sz="1400" b="1" dirty="0">
-                <a:solidFill>
-                  <a:schemeClr val="bg1"/>
-                </a:solidFill>
-              </a:rPr>
-              <a:t>2</a:t>
-            </a:r>
-            <a:endParaRPr lang="en-US" sz="1400" dirty="0"/>
-          </a:p>
-        </p:txBody>
-      </p:sp>
-      <p:sp>
-        <p:nvSpPr>
-          <p:cNvPr id="9" name="Text 6"/>
-          <p:cNvSpPr txBox="1"/>
-          <p:nvPr/>
-        </p:nvSpPr>
-        <p:spPr>
-          <a:xfrm>
-            <a:off x="6263640" y="2194560"/>
-            <a:ext cx="2468880" cy="868680"/>
-          </a:xfrm>
-          <a:prstGeom prst="rect">
-            <a:avLst/>
-          </a:prstGeom>
-          <a:noFill/>
-          <a:ln/>
-        </p:spPr>
-        <p:txBody>
-          <a:bodyPr wrap="square" lIns="0" tIns="0" rIns="0" bIns="0" rtlCol="0" anchor="t"/>
-          <a:lstStyle/>
-          <a:p>
-            <a:pPr indent="0" marL="0">
-              <a:buNone/>
-            </a:pPr>
-            <a:r>
-              <a:rPr lang="en-US" sz="1600" b="1" dirty="0">
-                <a:solidFill>
-                  <a:schemeClr val="tx1"/>
-                </a:solidFill>
-              </a:rPr>
-              <a:t>Animated drawing</a:t>
-            </a:r>
-            <a:endParaRPr lang="en-US" sz="1600" dirty="0"/>
-          </a:p>
-          <a:p>
-            <a:pPr indent="0" marL="0">
-              <a:buNone/>
-            </a:pPr>
-            <a:r>
-              <a:rPr lang="en-US" sz="1400" dirty="0">
-                <a:solidFill>
-                  <a:schemeClr val="tx2"/>
-                </a:solidFill>
-              </a:rPr>
-              <a:t>Each river draws itself in, so students see where it flows</a:t>
-            </a:r>
-            <a:endParaRPr lang="en-US" sz="1600" dirty="0"/>
-          </a:p>
-        </p:txBody>
-      </p:sp>
-      <p:sp>
-        <p:nvSpPr>
-          <p:cNvPr id="10" name="Step 3"/>
-          <p:cNvSpPr/>
-          <p:nvPr/>
-        </p:nvSpPr>
-        <p:spPr>
-          <a:xfrm>
-            <a:off x="5715000" y="3200400"/>
-            <a:ext cx="384048" cy="384048"/>
-          </a:xfrm>
-          <a:prstGeom prst="ellipse">
-            <a:avLst/>
-          </a:prstGeom>
-          <a:solidFill>
-            <a:schemeClr val="accent1"/>
-          </a:solidFill>
-          <a:ln/>
-        </p:spPr>
-      </p:sp>
-      <p:sp>
-        <p:nvSpPr>
-          <p:cNvPr id="11" name="Text 8"/>
-          <p:cNvSpPr txBox="1"/>
-          <p:nvPr/>
-        </p:nvSpPr>
-        <p:spPr>
-          <a:xfrm>
-            <a:off x="5715000" y="3200400"/>
-            <a:ext cx="384048" cy="384048"/>
-          </a:xfrm>
-          <a:prstGeom prst="rect">
-            <a:avLst/>
-          </a:prstGeom>
-          <a:noFill/>
-          <a:ln/>
-        </p:spPr>
-        <p:txBody>
-          <a:bodyPr wrap="square" lIns="0" tIns="0" rIns="0" bIns="0" rtlCol="0" anchor="ctr"/>
-          <a:lstStyle/>
-          <a:p>
-            <a:pPr algn="ctr" indent="0" marL="0">
-              <a:buNone/>
-            </a:pPr>
-            <a:r>
-              <a:rPr lang="en-US" sz="1400" b="1" dirty="0">
-                <a:solidFill>
-                  <a:schemeClr val="bg1"/>
-                </a:solidFill>
-              </a:rPr>
-              <a:t>3</a:t>
-            </a:r>
-            <a:endParaRPr lang="en-US" sz="1400" dirty="0"/>
-          </a:p>
-        </p:txBody>
-      </p:sp>
-      <p:sp>
-        <p:nvSpPr>
-          <p:cNvPr id="12" name="Text 9"/>
-          <p:cNvSpPr txBox="1"/>
-          <p:nvPr/>
-        </p:nvSpPr>
-        <p:spPr>
-          <a:xfrm>
-            <a:off x="6263640" y="3154680"/>
-            <a:ext cx="2468880" cy="868680"/>
-          </a:xfrm>
-          <a:prstGeom prst="rect">
-            <a:avLst/>
-          </a:prstGeom>
-          <a:noFill/>
-          <a:ln/>
-        </p:spPr>
-        <p:txBody>
-          <a:bodyPr wrap="square" lIns="0" tIns="0" rIns="0" bIns="0" rtlCol="0" anchor="t"/>
-          <a:lstStyle/>
-          <a:p>
-            <a:pPr indent="0" marL="0">
-              <a:buNone/>
-            </a:pPr>
-            <a:r>
-              <a:rPr lang="en-US" sz="1600" b="1" dirty="0">
-                <a:solidFill>
-                  <a:schemeClr val="tx1"/>
-                </a:solidFill>
-              </a:rPr>
-              <a:t>States overlay</a:t>
-            </a:r>
-            <a:endParaRPr lang="en-US" sz="1600" dirty="0"/>
-          </a:p>
-          <a:p>
-            <a:pPr indent="0" marL="0">
-              <a:buNone/>
-            </a:pPr>
-            <a:r>
-              <a:rPr lang="en-US" sz="1400" dirty="0">
-                <a:solidFill>
-                  <a:schemeClr val="tx2"/>
-                </a:solidFill>
-              </a:rPr>
-              <a:t>Switch the state boundaries on to link rivers to regions</a:t>
-            </a:r>
-            <a:endParaRPr lang="en-US" sz="1600" dirty="0"/>
-          </a:p>
-        </p:txBody>
-      </p:sp>
       <p:sp>
         <p:nvSpPr>
           <p:cNvPr id="25" name="Slide Number Placeholder 0"/>
@@ -2879,333 +3109,15 @@
                   <a:schemeClr val="tx1"/>
                 </a:solidFill>
               </a:rPr>
-              <a:t>Annotate: draw and label a blank map</a:t>
+              <a:t>Every river, traced the way the exam expects</a:t>
             </a:r>
             <a:endParaRPr lang="en-US" sz="2800" dirty="0"/>
-          </a:p>
-        </p:txBody>
-      </p:sp>
-      <p:sp>
-        <p:nvSpPr>
-          <p:cNvPr id="3" name="Step 1"/>
-          <p:cNvSpPr/>
-          <p:nvPr/>
-        </p:nvSpPr>
-        <p:spPr>
-          <a:xfrm>
-            <a:off x="457200" y="1280160"/>
-            <a:ext cx="384048" cy="384048"/>
-          </a:xfrm>
-          <a:prstGeom prst="ellipse">
-            <a:avLst/>
-          </a:prstGeom>
-          <a:solidFill>
-            <a:schemeClr val="accent1"/>
-          </a:solidFill>
-          <a:ln/>
-        </p:spPr>
-      </p:sp>
-      <p:sp>
-        <p:nvSpPr>
-          <p:cNvPr id="4" name="Text 2"/>
-          <p:cNvSpPr txBox="1"/>
-          <p:nvPr/>
-        </p:nvSpPr>
-        <p:spPr>
-          <a:xfrm>
-            <a:off x="457200" y="1280160"/>
-            <a:ext cx="384048" cy="384048"/>
-          </a:xfrm>
-          <a:prstGeom prst="rect">
-            <a:avLst/>
-          </a:prstGeom>
-          <a:noFill/>
-          <a:ln/>
-        </p:spPr>
-        <p:txBody>
-          <a:bodyPr wrap="square" lIns="0" tIns="0" rIns="0" bIns="0" rtlCol="0" anchor="ctr"/>
-          <a:lstStyle/>
-          <a:p>
-            <a:pPr algn="ctr" indent="0" marL="0">
-              <a:buNone/>
-            </a:pPr>
-            <a:r>
-              <a:rPr lang="en-US" sz="1400" b="1" dirty="0">
-                <a:solidFill>
-                  <a:schemeClr val="bg1"/>
-                </a:solidFill>
-              </a:rPr>
-              <a:t>1</a:t>
-            </a:r>
-            <a:endParaRPr lang="en-US" sz="1400" dirty="0"/>
-          </a:p>
-        </p:txBody>
-      </p:sp>
-      <p:sp>
-        <p:nvSpPr>
-          <p:cNvPr id="5" name="Text 3"/>
-          <p:cNvSpPr txBox="1"/>
-          <p:nvPr/>
-        </p:nvSpPr>
-        <p:spPr>
-          <a:xfrm>
-            <a:off x="1005840" y="1234440"/>
-            <a:ext cx="2560320" cy="868680"/>
-          </a:xfrm>
-          <a:prstGeom prst="rect">
-            <a:avLst/>
-          </a:prstGeom>
-          <a:noFill/>
-          <a:ln/>
-        </p:spPr>
-        <p:txBody>
-          <a:bodyPr wrap="square" lIns="0" tIns="0" rIns="0" bIns="0" rtlCol="0" anchor="t"/>
-          <a:lstStyle/>
-          <a:p>
-            <a:pPr indent="0" marL="0">
-              <a:buNone/>
-            </a:pPr>
-            <a:r>
-              <a:rPr lang="en-US" sz="1600" b="1" dirty="0">
-                <a:solidFill>
-                  <a:schemeClr val="tx1"/>
-                </a:solidFill>
-              </a:rPr>
-              <a:t>Freehand drawing</a:t>
-            </a:r>
-            <a:endParaRPr lang="en-US" sz="1600" dirty="0"/>
-          </a:p>
-          <a:p>
-            <a:pPr indent="0" marL="0">
-              <a:buNone/>
-            </a:pPr>
-            <a:r>
-              <a:rPr lang="en-US" sz="1400" dirty="0">
-                <a:solidFill>
-                  <a:schemeClr val="tx2"/>
-                </a:solidFill>
-              </a:rPr>
-              <a:t>Four map colours (water, land, vegetation, ink) and a stroke-width slider</a:t>
-            </a:r>
-            <a:endParaRPr lang="en-US" sz="1600" dirty="0"/>
-          </a:p>
-        </p:txBody>
-      </p:sp>
-      <p:sp>
-        <p:nvSpPr>
-          <p:cNvPr id="6" name="Step 2"/>
-          <p:cNvSpPr/>
-          <p:nvPr/>
-        </p:nvSpPr>
-        <p:spPr>
-          <a:xfrm>
-            <a:off x="457200" y="2240280"/>
-            <a:ext cx="384048" cy="384048"/>
-          </a:xfrm>
-          <a:prstGeom prst="ellipse">
-            <a:avLst/>
-          </a:prstGeom>
-          <a:solidFill>
-            <a:schemeClr val="accent1"/>
-          </a:solidFill>
-          <a:ln/>
-        </p:spPr>
-      </p:sp>
-      <p:sp>
-        <p:nvSpPr>
-          <p:cNvPr id="7" name="Text 5"/>
-          <p:cNvSpPr txBox="1"/>
-          <p:nvPr/>
-        </p:nvSpPr>
-        <p:spPr>
-          <a:xfrm>
-            <a:off x="457200" y="2240280"/>
-            <a:ext cx="384048" cy="384048"/>
-          </a:xfrm>
-          <a:prstGeom prst="rect">
-            <a:avLst/>
-          </a:prstGeom>
-          <a:noFill/>
-          <a:ln/>
-        </p:spPr>
-        <p:txBody>
-          <a:bodyPr wrap="square" lIns="0" tIns="0" rIns="0" bIns="0" rtlCol="0" anchor="ctr"/>
-          <a:lstStyle/>
-          <a:p>
-            <a:pPr algn="ctr" indent="0" marL="0">
-              <a:buNone/>
-            </a:pPr>
-            <a:r>
-              <a:rPr lang="en-US" sz="1400" b="1" dirty="0">
-                <a:solidFill>
-                  <a:schemeClr val="bg1"/>
-                </a:solidFill>
-              </a:rPr>
-              <a:t>2</a:t>
-            </a:r>
-            <a:endParaRPr lang="en-US" sz="1400" dirty="0"/>
-          </a:p>
-        </p:txBody>
-      </p:sp>
-      <p:sp>
-        <p:nvSpPr>
-          <p:cNvPr id="8" name="Text 6"/>
-          <p:cNvSpPr txBox="1"/>
-          <p:nvPr/>
-        </p:nvSpPr>
-        <p:spPr>
-          <a:xfrm>
-            <a:off x="1005840" y="2194560"/>
-            <a:ext cx="2560320" cy="868680"/>
-          </a:xfrm>
-          <a:prstGeom prst="rect">
-            <a:avLst/>
-          </a:prstGeom>
-          <a:noFill/>
-          <a:ln/>
-        </p:spPr>
-        <p:txBody>
-          <a:bodyPr wrap="square" lIns="0" tIns="0" rIns="0" bIns="0" rtlCol="0" anchor="t"/>
-          <a:lstStyle/>
-          <a:p>
-            <a:pPr indent="0" marL="0">
-              <a:buNone/>
-            </a:pPr>
-            <a:r>
-              <a:rPr lang="en-US" sz="1600" b="1" dirty="0">
-                <a:solidFill>
-                  <a:schemeClr val="tx1"/>
-                </a:solidFill>
-              </a:rPr>
-              <a:t>Text labels</a:t>
-            </a:r>
-            <a:endParaRPr lang="en-US" sz="1600" dirty="0"/>
-          </a:p>
-          <a:p>
-            <a:pPr indent="0" marL="0">
-              <a:buNone/>
-            </a:pPr>
-            <a:r>
-              <a:rPr lang="en-US" sz="1400" dirty="0">
-                <a:solidFill>
-                  <a:schemeClr val="tx2"/>
-                </a:solidFill>
-              </a:rPr>
-              <a:t>Type a place name and drop it where you last drew</a:t>
-            </a:r>
-            <a:endParaRPr lang="en-US" sz="1600" dirty="0"/>
-          </a:p>
-        </p:txBody>
-      </p:sp>
-      <p:sp>
-        <p:nvSpPr>
-          <p:cNvPr id="9" name="Step 3"/>
-          <p:cNvSpPr/>
-          <p:nvPr/>
-        </p:nvSpPr>
-        <p:spPr>
-          <a:xfrm>
-            <a:off x="457200" y="3200400"/>
-            <a:ext cx="384048" cy="384048"/>
-          </a:xfrm>
-          <a:prstGeom prst="ellipse">
-            <a:avLst/>
-          </a:prstGeom>
-          <a:solidFill>
-            <a:schemeClr val="accent1"/>
-          </a:solidFill>
-          <a:ln/>
-        </p:spPr>
-      </p:sp>
-      <p:sp>
-        <p:nvSpPr>
-          <p:cNvPr id="10" name="Text 8"/>
-          <p:cNvSpPr txBox="1"/>
-          <p:nvPr/>
-        </p:nvSpPr>
-        <p:spPr>
-          <a:xfrm>
-            <a:off x="457200" y="3200400"/>
-            <a:ext cx="384048" cy="384048"/>
-          </a:xfrm>
-          <a:prstGeom prst="rect">
-            <a:avLst/>
-          </a:prstGeom>
-          <a:noFill/>
-          <a:ln/>
-        </p:spPr>
-        <p:txBody>
-          <a:bodyPr wrap="square" lIns="0" tIns="0" rIns="0" bIns="0" rtlCol="0" anchor="ctr"/>
-          <a:lstStyle/>
-          <a:p>
-            <a:pPr algn="ctr" indent="0" marL="0">
-              <a:buNone/>
-            </a:pPr>
-            <a:r>
-              <a:rPr lang="en-US" sz="1400" b="1" dirty="0">
-                <a:solidFill>
-                  <a:schemeClr val="bg1"/>
-                </a:solidFill>
-              </a:rPr>
-              <a:t>3</a:t>
-            </a:r>
-            <a:endParaRPr lang="en-US" sz="1400" dirty="0"/>
-          </a:p>
-        </p:txBody>
-      </p:sp>
-      <p:sp>
-        <p:nvSpPr>
-          <p:cNvPr id="11" name="Text 9"/>
-          <p:cNvSpPr txBox="1"/>
-          <p:nvPr/>
-        </p:nvSpPr>
-        <p:spPr>
-          <a:xfrm>
-            <a:off x="1005840" y="3154680"/>
-            <a:ext cx="2560320" cy="868680"/>
-          </a:xfrm>
-          <a:prstGeom prst="rect">
-            <a:avLst/>
-          </a:prstGeom>
-          <a:noFill/>
-          <a:ln/>
-        </p:spPr>
-        <p:txBody>
-          <a:bodyPr wrap="square" lIns="0" tIns="0" rIns="0" bIns="0" rtlCol="0" anchor="t"/>
-          <a:lstStyle/>
-          <a:p>
-            <a:pPr indent="0" marL="0">
-              <a:buNone/>
-            </a:pPr>
-            <a:r>
-              <a:rPr lang="en-US" sz="1600" b="1" dirty="0">
-                <a:solidFill>
-                  <a:schemeClr val="tx1"/>
-                </a:solidFill>
-              </a:rPr>
-              <a:t>Submit to teacher</a:t>
-            </a:r>
-            <a:endParaRPr lang="en-US" sz="1600" dirty="0"/>
-          </a:p>
-          <a:p>
-            <a:pPr indent="0" marL="0">
-              <a:buNone/>
-            </a:pPr>
-            <a:r>
-              <a:rPr lang="en-US" sz="1400" dirty="0">
-                <a:solidFill>
-                  <a:schemeClr val="tx2"/>
-                </a:solidFill>
-              </a:rPr>
-              <a:t>The canvas is sent to the server as a PNG for review</a:t>
-            </a:r>
-            <a:endParaRPr lang="en-US" sz="1600" dirty="0"/>
           </a:p>
         </p:txBody>
       </p:sp>
       <p:pic>
         <p:nvPicPr>
-          <p:cNvPr id="12" name="Screenshot" descr="student.jpg">    </p:cNvPr>
+          <p:cNvPr id="3" name="Screenshot" descr="rivers.jpg">    </p:cNvPr>
           <p:cNvPicPr>
             <a:picLocks noChangeAspect="1"/>
           </p:cNvPicPr>
@@ -3219,7 +3131,7 @@
         </p:blipFill>
         <p:spPr>
           <a:xfrm>
-            <a:off x="3749040" y="1234440"/>
+            <a:off x="457200" y="1234440"/>
             <a:ext cx="4937760" cy="2777490"/>
           </a:xfrm>
           <a:prstGeom prst="rect">
@@ -3234,6 +3146,157 @@
           </a:effectLst>
         </p:spPr>
       </p:pic>
+      <p:sp>
+        <p:nvSpPr>
+          <p:cNvPr id="4" name="Text 1"/>
+          <p:cNvSpPr txBox="1"/>
+          <p:nvPr/>
+        </p:nvSpPr>
+        <p:spPr>
+          <a:xfrm>
+            <a:off x="5715000" y="1143000"/>
+            <a:ext cx="1188720" cy="822960"/>
+          </a:xfrm>
+          <a:prstGeom prst="rect">
+            <a:avLst/>
+          </a:prstGeom>
+          <a:noFill/>
+          <a:ln/>
+        </p:spPr>
+        <p:txBody>
+          <a:bodyPr wrap="square" lIns="0" tIns="0" rIns="0" bIns="0" rtlCol="0" anchor="ctr"/>
+          <a:lstStyle/>
+          <a:p>
+            <a:pPr indent="0" marL="0">
+              <a:buNone/>
+            </a:pPr>
+            <a:r>
+              <a:rPr lang="en-US" sz="5400" b="1" dirty="0">
+                <a:solidFill>
+                  <a:schemeClr val="accent2"/>
+                </a:solidFill>
+                <a:latin typeface="Cambria" pitchFamily="34" charset="0"/>
+                <a:ea typeface="Cambria" pitchFamily="34" charset="-122"/>
+                <a:cs typeface="Cambria" pitchFamily="34" charset="-120"/>
+              </a:rPr>
+              <a:t>20</a:t>
+            </a:r>
+            <a:endParaRPr lang="en-US" sz="5400" dirty="0"/>
+          </a:p>
+        </p:txBody>
+      </p:sp>
+      <p:sp>
+        <p:nvSpPr>
+          <p:cNvPr id="5" name="Text 2"/>
+          <p:cNvSpPr txBox="1"/>
+          <p:nvPr/>
+        </p:nvSpPr>
+        <p:spPr>
+          <a:xfrm>
+            <a:off x="6858000" y="1188720"/>
+            <a:ext cx="1828800" cy="731520"/>
+          </a:xfrm>
+          <a:prstGeom prst="rect">
+            <a:avLst/>
+          </a:prstGeom>
+          <a:noFill/>
+          <a:ln/>
+        </p:spPr>
+        <p:txBody>
+          <a:bodyPr wrap="square" lIns="0" tIns="0" rIns="0" bIns="0" rtlCol="0" anchor="ctr"/>
+          <a:lstStyle/>
+          <a:p>
+            <a:pPr indent="0" marL="0">
+              <a:buNone/>
+            </a:pPr>
+            <a:r>
+              <a:rPr lang="en-US" sz="1400" dirty="0">
+                <a:solidFill>
+                  <a:schemeClr val="tx2"/>
+                </a:solidFill>
+              </a:rPr>
+              <a:t>major rivers, from the Indus to the Kaveri</a:t>
+            </a:r>
+            <a:endParaRPr lang="en-US" sz="1400" dirty="0"/>
+          </a:p>
+        </p:txBody>
+      </p:sp>
+      <p:sp>
+        <p:nvSpPr>
+          <p:cNvPr id="6" name="Text 3"/>
+          <p:cNvSpPr txBox="1"/>
+          <p:nvPr/>
+        </p:nvSpPr>
+        <p:spPr>
+          <a:xfrm>
+            <a:off x="5715000" y="2194560"/>
+            <a:ext cx="3017520" cy="2286000"/>
+          </a:xfrm>
+          <a:prstGeom prst="rect">
+            <a:avLst/>
+          </a:prstGeom>
+          <a:noFill/>
+          <a:ln/>
+        </p:spPr>
+        <p:txBody>
+          <a:bodyPr wrap="square" lIns="0" tIns="0" rIns="0" bIns="0" rtlCol="0" anchor="t"/>
+          <a:lstStyle/>
+          <a:p>
+            <a:pPr marL="342900" indent="-342900">
+              <a:spcAft>
+                <a:spcPts val="800"/>
+              </a:spcAft>
+              <a:buSzPct val="100000"/>
+              <a:buChar char="•"/>
+            </a:pPr>
+            <a:r>
+              <a:rPr lang="en-US" sz="1400" dirty="0">
+                <a:solidFill>
+                  <a:schemeClr val="tx2"/>
+                </a:solidFill>
+              </a:rPr>
+              <a:t>We carefully traced each river to match the answer students are expected to draw in the exam.</a:t>
+            </a:r>
+            <a:endParaRPr lang="en-US" sz="1400" dirty="0"/>
+          </a:p>
+          <a:p>
+            <a:pPr marL="342900" indent="-342900">
+              <a:spcAft>
+                <a:spcPts val="800"/>
+              </a:spcAft>
+              <a:buSzPct val="100000"/>
+              <a:buChar char="•"/>
+            </a:pPr>
+            <a:r>
+              <a:rPr lang="en-US" sz="1400" dirty="0">
+                <a:solidFill>
+                  <a:schemeClr val="tx2"/>
+                </a:solidFill>
+              </a:rPr>
+              <a:t>Show one river at a time, or all of them together.</a:t>
+            </a:r>
+            <a:endParaRPr lang="en-US" sz="1400" dirty="0"/>
+          </a:p>
+          <a:p>
+            <a:pPr marL="342900" indent="-342900">
+              <a:spcAft>
+                <a:spcPts val="800"/>
+              </a:spcAft>
+              <a:buSzPct val="100000"/>
+              <a:buChar char="•"/>
+            </a:pPr>
+            <a:r>
+              <a:rPr lang="en-US" sz="1400" dirty="0">
+                <a:solidFill>
+                  <a:schemeClr val="tx2"/>
+                </a:solidFill>
+              </a:rPr>
+              <a:t>Add the state boundaries to see which states each river flows through.</a:t>
+            </a:r>
+            <a:endParaRPr lang="en-US" sz="1400" dirty="0"/>
+          </a:p>
+        </p:txBody>
+      </p:sp>
       <p:sp>
         <p:nvSpPr>
           <p:cNvPr id="25" name="Slide Number Placeholder 0"/>
@@ -3336,15 +3399,333 @@
                   <a:schemeClr val="tx1"/>
                 </a:solidFill>
               </a:rPr>
-              <a:t>Test Yourself: practise, then check</a:t>
+              <a:t>Practise on a blank map, just like the exam</a:t>
             </a:r>
             <a:endParaRPr lang="en-US" sz="2800" dirty="0"/>
+          </a:p>
+        </p:txBody>
+      </p:sp>
+      <p:sp>
+        <p:nvSpPr>
+          <p:cNvPr id="3" name="Step 1"/>
+          <p:cNvSpPr/>
+          <p:nvPr/>
+        </p:nvSpPr>
+        <p:spPr>
+          <a:xfrm>
+            <a:off x="457200" y="1280160"/>
+            <a:ext cx="384048" cy="384048"/>
+          </a:xfrm>
+          <a:prstGeom prst="ellipse">
+            <a:avLst/>
+          </a:prstGeom>
+          <a:solidFill>
+            <a:schemeClr val="accent1"/>
+          </a:solidFill>
+          <a:ln/>
+        </p:spPr>
+      </p:sp>
+      <p:sp>
+        <p:nvSpPr>
+          <p:cNvPr id="4" name="Text 2"/>
+          <p:cNvSpPr txBox="1"/>
+          <p:nvPr/>
+        </p:nvSpPr>
+        <p:spPr>
+          <a:xfrm>
+            <a:off x="457200" y="1280160"/>
+            <a:ext cx="384048" cy="384048"/>
+          </a:xfrm>
+          <a:prstGeom prst="rect">
+            <a:avLst/>
+          </a:prstGeom>
+          <a:noFill/>
+          <a:ln/>
+        </p:spPr>
+        <p:txBody>
+          <a:bodyPr wrap="square" lIns="0" tIns="0" rIns="0" bIns="0" rtlCol="0" anchor="ctr"/>
+          <a:lstStyle/>
+          <a:p>
+            <a:pPr algn="ctr" indent="0" marL="0">
+              <a:buNone/>
+            </a:pPr>
+            <a:r>
+              <a:rPr lang="en-US" sz="1400" b="1" dirty="0">
+                <a:solidFill>
+                  <a:schemeClr val="bg1"/>
+                </a:solidFill>
+              </a:rPr>
+              <a:t>1</a:t>
+            </a:r>
+            <a:endParaRPr lang="en-US" sz="1400" dirty="0"/>
+          </a:p>
+        </p:txBody>
+      </p:sp>
+      <p:sp>
+        <p:nvSpPr>
+          <p:cNvPr id="5" name="Text 3"/>
+          <p:cNvSpPr txBox="1"/>
+          <p:nvPr/>
+        </p:nvSpPr>
+        <p:spPr>
+          <a:xfrm>
+            <a:off x="1005840" y="1234440"/>
+            <a:ext cx="2560320" cy="868680"/>
+          </a:xfrm>
+          <a:prstGeom prst="rect">
+            <a:avLst/>
+          </a:prstGeom>
+          <a:noFill/>
+          <a:ln/>
+        </p:spPr>
+        <p:txBody>
+          <a:bodyPr wrap="square" lIns="0" tIns="0" rIns="0" bIns="0" rtlCol="0" anchor="t"/>
+          <a:lstStyle/>
+          <a:p>
+            <a:pPr indent="0" marL="0">
+              <a:buNone/>
+            </a:pPr>
+            <a:r>
+              <a:rPr lang="en-US" sz="1600" b="1" dirty="0">
+                <a:solidFill>
+                  <a:schemeClr val="tx1"/>
+                </a:solidFill>
+              </a:rPr>
+              <a:t>Draw the rivers</a:t>
+            </a:r>
+            <a:endParaRPr lang="en-US" sz="1600" dirty="0"/>
+          </a:p>
+          <a:p>
+            <a:pPr indent="0" marL="0">
+              <a:buNone/>
+            </a:pPr>
+            <a:r>
+              <a:rPr lang="en-US" sz="1400" dirty="0">
+                <a:solidFill>
+                  <a:schemeClr val="tx2"/>
+                </a:solidFill>
+              </a:rPr>
+              <a:t>Pick a colour, such as blue for water, and trace the river onto the map</a:t>
+            </a:r>
+            <a:endParaRPr lang="en-US" sz="1600" dirty="0"/>
+          </a:p>
+        </p:txBody>
+      </p:sp>
+      <p:sp>
+        <p:nvSpPr>
+          <p:cNvPr id="6" name="Step 2"/>
+          <p:cNvSpPr/>
+          <p:nvPr/>
+        </p:nvSpPr>
+        <p:spPr>
+          <a:xfrm>
+            <a:off x="457200" y="2240280"/>
+            <a:ext cx="384048" cy="384048"/>
+          </a:xfrm>
+          <a:prstGeom prst="ellipse">
+            <a:avLst/>
+          </a:prstGeom>
+          <a:solidFill>
+            <a:schemeClr val="accent1"/>
+          </a:solidFill>
+          <a:ln/>
+        </p:spPr>
+      </p:sp>
+      <p:sp>
+        <p:nvSpPr>
+          <p:cNvPr id="7" name="Text 5"/>
+          <p:cNvSpPr txBox="1"/>
+          <p:nvPr/>
+        </p:nvSpPr>
+        <p:spPr>
+          <a:xfrm>
+            <a:off x="457200" y="2240280"/>
+            <a:ext cx="384048" cy="384048"/>
+          </a:xfrm>
+          <a:prstGeom prst="rect">
+            <a:avLst/>
+          </a:prstGeom>
+          <a:noFill/>
+          <a:ln/>
+        </p:spPr>
+        <p:txBody>
+          <a:bodyPr wrap="square" lIns="0" tIns="0" rIns="0" bIns="0" rtlCol="0" anchor="ctr"/>
+          <a:lstStyle/>
+          <a:p>
+            <a:pPr algn="ctr" indent="0" marL="0">
+              <a:buNone/>
+            </a:pPr>
+            <a:r>
+              <a:rPr lang="en-US" sz="1400" b="1" dirty="0">
+                <a:solidFill>
+                  <a:schemeClr val="bg1"/>
+                </a:solidFill>
+              </a:rPr>
+              <a:t>2</a:t>
+            </a:r>
+            <a:endParaRPr lang="en-US" sz="1400" dirty="0"/>
+          </a:p>
+        </p:txBody>
+      </p:sp>
+      <p:sp>
+        <p:nvSpPr>
+          <p:cNvPr id="8" name="Text 6"/>
+          <p:cNvSpPr txBox="1"/>
+          <p:nvPr/>
+        </p:nvSpPr>
+        <p:spPr>
+          <a:xfrm>
+            <a:off x="1005840" y="2194560"/>
+            <a:ext cx="2560320" cy="868680"/>
+          </a:xfrm>
+          <a:prstGeom prst="rect">
+            <a:avLst/>
+          </a:prstGeom>
+          <a:noFill/>
+          <a:ln/>
+        </p:spPr>
+        <p:txBody>
+          <a:bodyPr wrap="square" lIns="0" tIns="0" rIns="0" bIns="0" rtlCol="0" anchor="t"/>
+          <a:lstStyle/>
+          <a:p>
+            <a:pPr indent="0" marL="0">
+              <a:buNone/>
+            </a:pPr>
+            <a:r>
+              <a:rPr lang="en-US" sz="1600" b="1" dirty="0">
+                <a:solidFill>
+                  <a:schemeClr val="tx1"/>
+                </a:solidFill>
+              </a:rPr>
+              <a:t>Name what you draw</a:t>
+            </a:r>
+            <a:endParaRPr lang="en-US" sz="1600" dirty="0"/>
+          </a:p>
+          <a:p>
+            <a:pPr indent="0" marL="0">
+              <a:buNone/>
+            </a:pPr>
+            <a:r>
+              <a:rPr lang="en-US" sz="1400" dirty="0">
+                <a:solidFill>
+                  <a:schemeClr val="tx2"/>
+                </a:solidFill>
+              </a:rPr>
+              <a:t>Add labels, just as the exam asks</a:t>
+            </a:r>
+            <a:endParaRPr lang="en-US" sz="1600" dirty="0"/>
+          </a:p>
+        </p:txBody>
+      </p:sp>
+      <p:sp>
+        <p:nvSpPr>
+          <p:cNvPr id="9" name="Step 3"/>
+          <p:cNvSpPr/>
+          <p:nvPr/>
+        </p:nvSpPr>
+        <p:spPr>
+          <a:xfrm>
+            <a:off x="457200" y="3200400"/>
+            <a:ext cx="384048" cy="384048"/>
+          </a:xfrm>
+          <a:prstGeom prst="ellipse">
+            <a:avLst/>
+          </a:prstGeom>
+          <a:solidFill>
+            <a:schemeClr val="accent1"/>
+          </a:solidFill>
+          <a:ln/>
+        </p:spPr>
+      </p:sp>
+      <p:sp>
+        <p:nvSpPr>
+          <p:cNvPr id="10" name="Text 8"/>
+          <p:cNvSpPr txBox="1"/>
+          <p:nvPr/>
+        </p:nvSpPr>
+        <p:spPr>
+          <a:xfrm>
+            <a:off x="457200" y="3200400"/>
+            <a:ext cx="384048" cy="384048"/>
+          </a:xfrm>
+          <a:prstGeom prst="rect">
+            <a:avLst/>
+          </a:prstGeom>
+          <a:noFill/>
+          <a:ln/>
+        </p:spPr>
+        <p:txBody>
+          <a:bodyPr wrap="square" lIns="0" tIns="0" rIns="0" bIns="0" rtlCol="0" anchor="ctr"/>
+          <a:lstStyle/>
+          <a:p>
+            <a:pPr algn="ctr" indent="0" marL="0">
+              <a:buNone/>
+            </a:pPr>
+            <a:r>
+              <a:rPr lang="en-US" sz="1400" b="1" dirty="0">
+                <a:solidFill>
+                  <a:schemeClr val="bg1"/>
+                </a:solidFill>
+              </a:rPr>
+              <a:t>3</a:t>
+            </a:r>
+            <a:endParaRPr lang="en-US" sz="1400" dirty="0"/>
+          </a:p>
+        </p:txBody>
+      </p:sp>
+      <p:sp>
+        <p:nvSpPr>
+          <p:cNvPr id="11" name="Text 9"/>
+          <p:cNvSpPr txBox="1"/>
+          <p:nvPr/>
+        </p:nvSpPr>
+        <p:spPr>
+          <a:xfrm>
+            <a:off x="1005840" y="3154680"/>
+            <a:ext cx="2560320" cy="868680"/>
+          </a:xfrm>
+          <a:prstGeom prst="rect">
+            <a:avLst/>
+          </a:prstGeom>
+          <a:noFill/>
+          <a:ln/>
+        </p:spPr>
+        <p:txBody>
+          <a:bodyPr wrap="square" lIns="0" tIns="0" rIns="0" bIns="0" rtlCol="0" anchor="t"/>
+          <a:lstStyle/>
+          <a:p>
+            <a:pPr indent="0" marL="0">
+              <a:buNone/>
+            </a:pPr>
+            <a:r>
+              <a:rPr lang="en-US" sz="1600" b="1" dirty="0">
+                <a:solidFill>
+                  <a:schemeClr val="tx1"/>
+                </a:solidFill>
+              </a:rPr>
+              <a:t>Start again any time</a:t>
+            </a:r>
+            <a:endParaRPr lang="en-US" sz="1600" dirty="0"/>
+          </a:p>
+          <a:p>
+            <a:pPr indent="0" marL="0">
+              <a:buNone/>
+            </a:pPr>
+            <a:r>
+              <a:rPr lang="en-US" sz="1400" dirty="0">
+                <a:solidFill>
+                  <a:schemeClr val="tx2"/>
+                </a:solidFill>
+              </a:rPr>
+              <a:t>Clear the map and try once more</a:t>
+            </a:r>
+            <a:endParaRPr lang="en-US" sz="1600" dirty="0"/>
           </a:p>
         </p:txBody>
       </p:sp>
       <p:pic>
         <p:nvPicPr>
-          <p:cNvPr id="3" name="Screenshot" descr="selftest.jpg">    </p:cNvPr>
+          <p:cNvPr id="12" name="Screenshot" descr="student.jpg">    </p:cNvPr>
           <p:cNvPicPr>
             <a:picLocks noChangeAspect="1"/>
           </p:cNvPicPr>
@@ -3358,7 +3739,7 @@
         </p:blipFill>
         <p:spPr>
           <a:xfrm>
-            <a:off x="457200" y="1234440"/>
+            <a:off x="3749040" y="1234440"/>
             <a:ext cx="4937760" cy="2777490"/>
           </a:xfrm>
           <a:prstGeom prst="rect">
@@ -3373,324 +3754,6 @@
           </a:effectLst>
         </p:spPr>
       </p:pic>
-      <p:sp>
-        <p:nvSpPr>
-          <p:cNvPr id="4" name="Step 1"/>
-          <p:cNvSpPr/>
-          <p:nvPr/>
-        </p:nvSpPr>
-        <p:spPr>
-          <a:xfrm>
-            <a:off x="5715000" y="1280160"/>
-            <a:ext cx="384048" cy="384048"/>
-          </a:xfrm>
-          <a:prstGeom prst="ellipse">
-            <a:avLst/>
-          </a:prstGeom>
-          <a:solidFill>
-            <a:schemeClr val="accent1"/>
-          </a:solidFill>
-          <a:ln/>
-        </p:spPr>
-      </p:sp>
-      <p:sp>
-        <p:nvSpPr>
-          <p:cNvPr id="5" name="Text 2"/>
-          <p:cNvSpPr txBox="1"/>
-          <p:nvPr/>
-        </p:nvSpPr>
-        <p:spPr>
-          <a:xfrm>
-            <a:off x="5715000" y="1280160"/>
-            <a:ext cx="384048" cy="384048"/>
-          </a:xfrm>
-          <a:prstGeom prst="rect">
-            <a:avLst/>
-          </a:prstGeom>
-          <a:noFill/>
-          <a:ln/>
-        </p:spPr>
-        <p:txBody>
-          <a:bodyPr wrap="square" lIns="0" tIns="0" rIns="0" bIns="0" rtlCol="0" anchor="ctr"/>
-          <a:lstStyle/>
-          <a:p>
-            <a:pPr algn="ctr" indent="0" marL="0">
-              <a:buNone/>
-            </a:pPr>
-            <a:r>
-              <a:rPr lang="en-US" sz="1400" b="1" dirty="0">
-                <a:solidFill>
-                  <a:schemeClr val="bg1"/>
-                </a:solidFill>
-              </a:rPr>
-              <a:t>1</a:t>
-            </a:r>
-            <a:endParaRPr lang="en-US" sz="1400" dirty="0"/>
-          </a:p>
-        </p:txBody>
-      </p:sp>
-      <p:sp>
-        <p:nvSpPr>
-          <p:cNvPr id="6" name="Text 3"/>
-          <p:cNvSpPr txBox="1"/>
-          <p:nvPr/>
-        </p:nvSpPr>
-        <p:spPr>
-          <a:xfrm>
-            <a:off x="6263640" y="1234440"/>
-            <a:ext cx="2468880" cy="868680"/>
-          </a:xfrm>
-          <a:prstGeom prst="rect">
-            <a:avLst/>
-          </a:prstGeom>
-          <a:noFill/>
-          <a:ln/>
-        </p:spPr>
-        <p:txBody>
-          <a:bodyPr wrap="square" lIns="0" tIns="0" rIns="0" bIns="0" rtlCol="0" anchor="t"/>
-          <a:lstStyle/>
-          <a:p>
-            <a:pPr indent="0" marL="0">
-              <a:buNone/>
-            </a:pPr>
-            <a:r>
-              <a:rPr lang="en-US" sz="1600" b="1" dirty="0">
-                <a:solidFill>
-                  <a:schemeClr val="tx1"/>
-                </a:solidFill>
-              </a:rPr>
-              <a:t>Guided traces</a:t>
-            </a:r>
-            <a:endParaRPr lang="en-US" sz="1600" dirty="0"/>
-          </a:p>
-          <a:p>
-            <a:pPr indent="0" marL="0">
-              <a:buNone/>
-            </a:pPr>
-            <a:r>
-              <a:rPr lang="en-US" sz="1400" dirty="0">
-                <a:solidFill>
-                  <a:schemeClr val="tx2"/>
-                </a:solidFill>
-              </a:rPr>
-              <a:t>Faint outlines of the Narmada, Tapi and Godavari to follow</a:t>
-            </a:r>
-            <a:endParaRPr lang="en-US" sz="1600" dirty="0"/>
-          </a:p>
-        </p:txBody>
-      </p:sp>
-      <p:sp>
-        <p:nvSpPr>
-          <p:cNvPr id="7" name="Step 2"/>
-          <p:cNvSpPr/>
-          <p:nvPr/>
-        </p:nvSpPr>
-        <p:spPr>
-          <a:xfrm>
-            <a:off x="5715000" y="2240280"/>
-            <a:ext cx="384048" cy="384048"/>
-          </a:xfrm>
-          <a:prstGeom prst="ellipse">
-            <a:avLst/>
-          </a:prstGeom>
-          <a:solidFill>
-            <a:schemeClr val="accent1"/>
-          </a:solidFill>
-          <a:ln/>
-        </p:spPr>
-      </p:sp>
-      <p:sp>
-        <p:nvSpPr>
-          <p:cNvPr id="8" name="Text 5"/>
-          <p:cNvSpPr txBox="1"/>
-          <p:nvPr/>
-        </p:nvSpPr>
-        <p:spPr>
-          <a:xfrm>
-            <a:off x="5715000" y="2240280"/>
-            <a:ext cx="384048" cy="384048"/>
-          </a:xfrm>
-          <a:prstGeom prst="rect">
-            <a:avLst/>
-          </a:prstGeom>
-          <a:noFill/>
-          <a:ln/>
-        </p:spPr>
-        <p:txBody>
-          <a:bodyPr wrap="square" lIns="0" tIns="0" rIns="0" bIns="0" rtlCol="0" anchor="ctr"/>
-          <a:lstStyle/>
-          <a:p>
-            <a:pPr algn="ctr" indent="0" marL="0">
-              <a:buNone/>
-            </a:pPr>
-            <a:r>
-              <a:rPr lang="en-US" sz="1400" b="1" dirty="0">
-                <a:solidFill>
-                  <a:schemeClr val="bg1"/>
-                </a:solidFill>
-              </a:rPr>
-              <a:t>2</a:t>
-            </a:r>
-            <a:endParaRPr lang="en-US" sz="1400" dirty="0"/>
-          </a:p>
-        </p:txBody>
-      </p:sp>
-      <p:sp>
-        <p:nvSpPr>
-          <p:cNvPr id="9" name="Text 6"/>
-          <p:cNvSpPr txBox="1"/>
-          <p:nvPr/>
-        </p:nvSpPr>
-        <p:spPr>
-          <a:xfrm>
-            <a:off x="6263640" y="2194560"/>
-            <a:ext cx="2468880" cy="868680"/>
-          </a:xfrm>
-          <a:prstGeom prst="rect">
-            <a:avLst/>
-          </a:prstGeom>
-          <a:noFill/>
-          <a:ln/>
-        </p:spPr>
-        <p:txBody>
-          <a:bodyPr wrap="square" lIns="0" tIns="0" rIns="0" bIns="0" rtlCol="0" anchor="t"/>
-          <a:lstStyle/>
-          <a:p>
-            <a:pPr indent="0" marL="0">
-              <a:buNone/>
-            </a:pPr>
-            <a:r>
-              <a:rPr lang="en-US" sz="1600" b="1" dirty="0">
-                <a:solidFill>
-                  <a:schemeClr val="tx1"/>
-                </a:solidFill>
-              </a:rPr>
-              <a:t>Reveal the states</a:t>
-            </a:r>
-            <a:endParaRPr lang="en-US" sz="1600" dirty="0"/>
-          </a:p>
-          <a:p>
-            <a:pPr indent="0" marL="0">
-              <a:buNone/>
-            </a:pPr>
-            <a:r>
-              <a:rPr lang="en-US" sz="1400" dirty="0">
-                <a:solidFill>
-                  <a:schemeClr val="tx2"/>
-                </a:solidFill>
-              </a:rPr>
-              <a:t>Show the states map to check where a river runs</a:t>
-            </a:r>
-            <a:endParaRPr lang="en-US" sz="1600" dirty="0"/>
-          </a:p>
-        </p:txBody>
-      </p:sp>
-      <p:sp>
-        <p:nvSpPr>
-          <p:cNvPr id="10" name="Step 3"/>
-          <p:cNvSpPr/>
-          <p:nvPr/>
-        </p:nvSpPr>
-        <p:spPr>
-          <a:xfrm>
-            <a:off x="5715000" y="3200400"/>
-            <a:ext cx="384048" cy="384048"/>
-          </a:xfrm>
-          <a:prstGeom prst="ellipse">
-            <a:avLst/>
-          </a:prstGeom>
-          <a:solidFill>
-            <a:schemeClr val="accent1"/>
-          </a:solidFill>
-          <a:ln/>
-        </p:spPr>
-      </p:sp>
-      <p:sp>
-        <p:nvSpPr>
-          <p:cNvPr id="11" name="Text 8"/>
-          <p:cNvSpPr txBox="1"/>
-          <p:nvPr/>
-        </p:nvSpPr>
-        <p:spPr>
-          <a:xfrm>
-            <a:off x="5715000" y="3200400"/>
-            <a:ext cx="384048" cy="384048"/>
-          </a:xfrm>
-          <a:prstGeom prst="rect">
-            <a:avLst/>
-          </a:prstGeom>
-          <a:noFill/>
-          <a:ln/>
-        </p:spPr>
-        <p:txBody>
-          <a:bodyPr wrap="square" lIns="0" tIns="0" rIns="0" bIns="0" rtlCol="0" anchor="ctr"/>
-          <a:lstStyle/>
-          <a:p>
-            <a:pPr algn="ctr" indent="0" marL="0">
-              <a:buNone/>
-            </a:pPr>
-            <a:r>
-              <a:rPr lang="en-US" sz="1400" b="1" dirty="0">
-                <a:solidFill>
-                  <a:schemeClr val="bg1"/>
-                </a:solidFill>
-              </a:rPr>
-              <a:t>3</a:t>
-            </a:r>
-            <a:endParaRPr lang="en-US" sz="1400" dirty="0"/>
-          </a:p>
-        </p:txBody>
-      </p:sp>
-      <p:sp>
-        <p:nvSpPr>
-          <p:cNvPr id="12" name="Text 9"/>
-          <p:cNvSpPr txBox="1"/>
-          <p:nvPr/>
-        </p:nvSpPr>
-        <p:spPr>
-          <a:xfrm>
-            <a:off x="6263640" y="3154680"/>
-            <a:ext cx="2468880" cy="868680"/>
-          </a:xfrm>
-          <a:prstGeom prst="rect">
-            <a:avLst/>
-          </a:prstGeom>
-          <a:noFill/>
-          <a:ln/>
-        </p:spPr>
-        <p:txBody>
-          <a:bodyPr wrap="square" lIns="0" tIns="0" rIns="0" bIns="0" rtlCol="0" anchor="t"/>
-          <a:lstStyle/>
-          <a:p>
-            <a:pPr indent="0" marL="0">
-              <a:buNone/>
-            </a:pPr>
-            <a:r>
-              <a:rPr lang="en-US" sz="1600" b="1" dirty="0">
-                <a:solidFill>
-                  <a:schemeClr val="tx1"/>
-                </a:solidFill>
-              </a:rPr>
-              <a:t>Keep your work</a:t>
-            </a:r>
-            <a:endParaRPr lang="en-US" sz="1600" dirty="0"/>
-          </a:p>
-          <a:p>
-            <a:pPr indent="0" marL="0">
-              <a:buNone/>
-            </a:pPr>
-            <a:r>
-              <a:rPr lang="en-US" sz="1400" dirty="0">
-                <a:solidFill>
-                  <a:schemeClr val="tx2"/>
-                </a:solidFill>
-              </a:rPr>
-              <a:t>Save the finished map as a PNG</a:t>
-            </a:r>
-            <a:endParaRPr lang="en-US" sz="1600" dirty="0"/>
-          </a:p>
-        </p:txBody>
-      </p:sp>
       <p:sp>
         <p:nvSpPr>
           <p:cNvPr id="25" name="Slide Number Placeholder 0"/>
@@ -3793,102 +3856,55 @@
                   <a:schemeClr val="tx1"/>
                 </a:solidFill>
               </a:rPr>
-              <a:t>A live loop between student and teacher</a:t>
+              <a:t>Students check their own answer straight away</a:t>
             </a:r>
             <a:endParaRPr lang="en-US" sz="2800" dirty="0"/>
           </a:p>
         </p:txBody>
       </p:sp>
-      <p:sp>
-        <p:nvSpPr>
-          <p:cNvPr id="3" name="Student"/>
+      <p:pic>
+        <p:nvPicPr>
+          <p:cNvPr id="3" name="Screenshot" descr="selftest2.jpg">    </p:cNvPr>
+          <p:cNvPicPr>
+            <a:picLocks noChangeAspect="1"/>
+          </p:cNvPicPr>
+          <p:nvPr/>
+        </p:nvPicPr>
+        <p:blipFill>
+          <a:blip r:embed="rId1"/>
+          <a:stretch>
+            <a:fillRect/>
+          </a:stretch>
+        </p:blipFill>
+        <p:spPr>
+          <a:xfrm>
+            <a:off x="457200" y="1234440"/>
+            <a:ext cx="4937760" cy="2777490"/>
+          </a:xfrm>
+          <a:prstGeom prst="rect">
+            <a:avLst/>
+          </a:prstGeom>
+          <a:effectLst>
+            <a:outerShdw sx="100000" sy="100000" kx="0" ky="0" algn="bl" rotWithShape="0" blurRad="101600" dist="25400" dir="5400000">
+              <a:srgbClr val="000000">
+                <a:alpha val="18000"/>
+              </a:srgbClr>
+            </a:outerShdw>
+          </a:effectLst>
+        </p:spPr>
+      </p:pic>
+      <p:sp>
+        <p:nvSpPr>
+          <p:cNvPr id="4" name="Step 1"/>
           <p:cNvSpPr/>
           <p:nvPr/>
         </p:nvSpPr>
         <p:spPr>
           <a:xfrm>
-            <a:off x="457200" y="1371600"/>
-            <a:ext cx="2514600" cy="1600200"/>
-          </a:xfrm>
-          <a:prstGeom prst="roundRect">
-            <a:avLst>
-              <a:gd name="adj" fmla="val 6857"/>
-            </a:avLst>
-          </a:prstGeom>
-          <a:solidFill>
-            <a:schemeClr val="bg2"/>
-          </a:solidFill>
-          <a:ln/>
-        </p:spPr>
-      </p:sp>
-      <p:sp>
-        <p:nvSpPr>
-          <p:cNvPr id="4" name="Text 2"/>
-          <p:cNvSpPr txBox="1"/>
-          <p:nvPr/>
-        </p:nvSpPr>
-        <p:spPr>
-          <a:xfrm>
-            <a:off x="640080" y="1508760"/>
-            <a:ext cx="2148840" cy="1325880"/>
-          </a:xfrm>
-          <a:prstGeom prst="rect">
-            <a:avLst/>
-          </a:prstGeom>
-          <a:noFill/>
-          <a:ln/>
-        </p:spPr>
-        <p:txBody>
-          <a:bodyPr wrap="square" lIns="0" tIns="0" rIns="0" bIns="0" rtlCol="0" anchor="t"/>
-          <a:lstStyle/>
-          <a:p>
-            <a:pPr indent="0" marL="0">
-              <a:spcAft>
-                <a:spcPts val="400"/>
-              </a:spcAft>
-              <a:buNone/>
-            </a:pPr>
-            <a:r>
-              <a:rPr lang="en-US" sz="1800" b="1" dirty="0">
-                <a:solidFill>
-                  <a:schemeClr val="tx1"/>
-                </a:solidFill>
-              </a:rPr>
-              <a:t>Student</a:t>
-            </a:r>
-            <a:endParaRPr lang="en-US" sz="1800" dirty="0"/>
-          </a:p>
-          <a:p>
-            <a:pPr indent="0" marL="0">
-              <a:spcAft>
-                <a:spcPts val="400"/>
-              </a:spcAft>
-              <a:buNone/>
-            </a:pPr>
-            <a:r>
-              <a:rPr lang="en-US" sz="1400" dirty="0">
-                <a:solidFill>
-                  <a:schemeClr val="tx2"/>
-                </a:solidFill>
-              </a:rPr>
-              <a:t>Draws and labels the map, then presses Submit</a:t>
-            </a:r>
-            <a:endParaRPr lang="en-US" sz="1800" dirty="0"/>
-          </a:p>
-        </p:txBody>
-      </p:sp>
-      <p:sp>
-        <p:nvSpPr>
-          <p:cNvPr id="5" name="Arrow"/>
-          <p:cNvSpPr/>
-          <p:nvPr/>
-        </p:nvSpPr>
-        <p:spPr>
-          <a:xfrm>
-            <a:off x="3017520" y="2029968"/>
-            <a:ext cx="274320" cy="274320"/>
-          </a:xfrm>
-          <a:prstGeom prst="rightArrow">
+            <a:off x="5715000" y="1280160"/>
+            <a:ext cx="384048" cy="384048"/>
+          </a:xfrm>
+          <a:prstGeom prst="ellipse">
             <a:avLst/>
           </a:prstGeom>
           <a:solidFill>
@@ -3899,94 +3915,102 @@
       </p:sp>
       <p:sp>
         <p:nvSpPr>
-          <p:cNvPr id="6" name="Express server"/>
+          <p:cNvPr id="5" name="Text 2"/>
+          <p:cNvSpPr txBox="1"/>
+          <p:nvPr/>
+        </p:nvSpPr>
+        <p:spPr>
+          <a:xfrm>
+            <a:off x="5715000" y="1280160"/>
+            <a:ext cx="384048" cy="384048"/>
+          </a:xfrm>
+          <a:prstGeom prst="rect">
+            <a:avLst/>
+          </a:prstGeom>
+          <a:noFill/>
+          <a:ln/>
+        </p:spPr>
+        <p:txBody>
+          <a:bodyPr wrap="square" lIns="0" tIns="0" rIns="0" bIns="0" rtlCol="0" anchor="ctr"/>
+          <a:lstStyle/>
+          <a:p>
+            <a:pPr algn="ctr" indent="0" marL="0">
+              <a:buNone/>
+            </a:pPr>
+            <a:r>
+              <a:rPr lang="en-US" sz="1400" b="1" dirty="0">
+                <a:solidFill>
+                  <a:schemeClr val="bg1"/>
+                </a:solidFill>
+              </a:rPr>
+              <a:t>1</a:t>
+            </a:r>
+            <a:endParaRPr lang="en-US" sz="1400" dirty="0"/>
+          </a:p>
+        </p:txBody>
+      </p:sp>
+      <p:sp>
+        <p:nvSpPr>
+          <p:cNvPr id="6" name="Text 3"/>
+          <p:cNvSpPr txBox="1"/>
+          <p:nvPr/>
+        </p:nvSpPr>
+        <p:spPr>
+          <a:xfrm>
+            <a:off x="6263640" y="1234440"/>
+            <a:ext cx="2468880" cy="868680"/>
+          </a:xfrm>
+          <a:prstGeom prst="rect">
+            <a:avLst/>
+          </a:prstGeom>
+          <a:noFill/>
+          <a:ln/>
+        </p:spPr>
+        <p:txBody>
+          <a:bodyPr wrap="square" lIns="0" tIns="0" rIns="0" bIns="0" rtlCol="0" anchor="t"/>
+          <a:lstStyle/>
+          <a:p>
+            <a:pPr indent="0" marL="0">
+              <a:buNone/>
+            </a:pPr>
+            <a:r>
+              <a:rPr lang="en-US" sz="1600" b="1" dirty="0">
+                <a:solidFill>
+                  <a:schemeClr val="tx1"/>
+                </a:solidFill>
+              </a:rPr>
+              <a:t>Follow the guide</a:t>
+            </a:r>
+            <a:endParaRPr lang="en-US" sz="1600" dirty="0"/>
+          </a:p>
+          <a:p>
+            <a:pPr indent="0" marL="0">
+              <a:buNone/>
+            </a:pPr>
+            <a:r>
+              <a:rPr lang="en-US" sz="1400" dirty="0">
+                <a:solidFill>
+                  <a:schemeClr val="tx2"/>
+                </a:solidFill>
+              </a:rPr>
+              <a:t>Faint outlines of the correct river path to trace over</a:t>
+            </a:r>
+            <a:endParaRPr lang="en-US" sz="1600" dirty="0"/>
+          </a:p>
+        </p:txBody>
+      </p:sp>
+      <p:sp>
+        <p:nvSpPr>
+          <p:cNvPr id="7" name="Step 2"/>
           <p:cNvSpPr/>
           <p:nvPr/>
         </p:nvSpPr>
         <p:spPr>
           <a:xfrm>
-            <a:off x="3337560" y="1371600"/>
-            <a:ext cx="2514600" cy="1600200"/>
-          </a:xfrm>
-          <a:prstGeom prst="roundRect">
-            <a:avLst>
-              <a:gd name="adj" fmla="val 6857"/>
-            </a:avLst>
-          </a:prstGeom>
-          <a:solidFill>
-            <a:schemeClr val="tx1"/>
-          </a:solidFill>
-          <a:ln/>
-        </p:spPr>
-      </p:sp>
-      <p:sp>
-        <p:nvSpPr>
-          <p:cNvPr id="7" name="Text 5"/>
-          <p:cNvSpPr txBox="1"/>
-          <p:nvPr/>
-        </p:nvSpPr>
-        <p:spPr>
-          <a:xfrm>
-            <a:off x="3520440" y="1508760"/>
-            <a:ext cx="2148840" cy="1325880"/>
-          </a:xfrm>
-          <a:prstGeom prst="rect">
-            <a:avLst/>
-          </a:prstGeom>
-          <a:noFill/>
-          <a:ln/>
-        </p:spPr>
-        <p:txBody>
-          <a:bodyPr wrap="square" lIns="0" tIns="0" rIns="0" bIns="0" rtlCol="0" anchor="t"/>
-          <a:lstStyle/>
-          <a:p>
-            <a:pPr indent="0" marL="0">
-              <a:spcAft>
-                <a:spcPts val="400"/>
-              </a:spcAft>
-              <a:buNone/>
-            </a:pPr>
-            <a:r>
-              <a:rPr lang="en-US" sz="1800" b="1" dirty="0">
-                <a:solidFill>
-                  <a:schemeClr val="accent5"/>
-                </a:solidFill>
-              </a:rPr>
-              <a:t>Express server</a:t>
-            </a:r>
-            <a:endParaRPr lang="en-US" sz="1800" dirty="0"/>
-          </a:p>
-          <a:p>
-            <a:pPr indent="0" marL="0">
-              <a:spcAft>
-                <a:spcPts val="400"/>
-              </a:spcAft>
-              <a:buNone/>
-            </a:pPr>
-            <a:r>
-              <a:rPr lang="en-US" sz="1400" dirty="0">
-                <a:solidFill>
-                  <a:schemeClr val="bg1"/>
-                </a:solidFill>
-              </a:rPr>
-              <a:t>POST /save-base64 stores the map as canvasData.png</a:t>
-            </a:r>
-            <a:endParaRPr lang="en-US" sz="1800" dirty="0"/>
-          </a:p>
-        </p:txBody>
-      </p:sp>
-      <p:sp>
-        <p:nvSpPr>
-          <p:cNvPr id="8" name="Arrow"/>
-          <p:cNvSpPr/>
-          <p:nvPr/>
-        </p:nvSpPr>
-        <p:spPr>
-          <a:xfrm>
-            <a:off x="5897880" y="2029968"/>
-            <a:ext cx="274320" cy="274320"/>
-          </a:xfrm>
-          <a:prstGeom prst="rightArrow">
+            <a:off x="5715000" y="2240280"/>
+            <a:ext cx="384048" cy="384048"/>
+          </a:xfrm>
+          <a:prstGeom prst="ellipse">
             <a:avLst/>
           </a:prstGeom>
           <a:solidFill>
@@ -3997,36 +4021,120 @@
       </p:sp>
       <p:sp>
         <p:nvSpPr>
-          <p:cNvPr id="9" name="Teacher"/>
+          <p:cNvPr id="8" name="Text 5"/>
+          <p:cNvSpPr txBox="1"/>
+          <p:nvPr/>
+        </p:nvSpPr>
+        <p:spPr>
+          <a:xfrm>
+            <a:off x="5715000" y="2240280"/>
+            <a:ext cx="384048" cy="384048"/>
+          </a:xfrm>
+          <a:prstGeom prst="rect">
+            <a:avLst/>
+          </a:prstGeom>
+          <a:noFill/>
+          <a:ln/>
+        </p:spPr>
+        <p:txBody>
+          <a:bodyPr wrap="square" lIns="0" tIns="0" rIns="0" bIns="0" rtlCol="0" anchor="ctr"/>
+          <a:lstStyle/>
+          <a:p>
+            <a:pPr algn="ctr" indent="0" marL="0">
+              <a:buNone/>
+            </a:pPr>
+            <a:r>
+              <a:rPr lang="en-US" sz="1400" b="1" dirty="0">
+                <a:solidFill>
+                  <a:schemeClr val="bg1"/>
+                </a:solidFill>
+              </a:rPr>
+              <a:t>2</a:t>
+            </a:r>
+            <a:endParaRPr lang="en-US" sz="1400" dirty="0"/>
+          </a:p>
+        </p:txBody>
+      </p:sp>
+      <p:sp>
+        <p:nvSpPr>
+          <p:cNvPr id="9" name="Text 6"/>
+          <p:cNvSpPr txBox="1"/>
+          <p:nvPr/>
+        </p:nvSpPr>
+        <p:spPr>
+          <a:xfrm>
+            <a:off x="6263640" y="2194560"/>
+            <a:ext cx="2468880" cy="868680"/>
+          </a:xfrm>
+          <a:prstGeom prst="rect">
+            <a:avLst/>
+          </a:prstGeom>
+          <a:noFill/>
+          <a:ln/>
+        </p:spPr>
+        <p:txBody>
+          <a:bodyPr wrap="square" lIns="0" tIns="0" rIns="0" bIns="0" rtlCol="0" anchor="t"/>
+          <a:lstStyle/>
+          <a:p>
+            <a:pPr indent="0" marL="0">
+              <a:buNone/>
+            </a:pPr>
+            <a:r>
+              <a:rPr lang="en-US" sz="1600" b="1" dirty="0">
+                <a:solidFill>
+                  <a:schemeClr val="tx1"/>
+                </a:solidFill>
+              </a:rPr>
+              <a:t>Reveal the states</a:t>
+            </a:r>
+            <a:endParaRPr lang="en-US" sz="1600" dirty="0"/>
+          </a:p>
+          <a:p>
+            <a:pPr indent="0" marL="0">
+              <a:buNone/>
+            </a:pPr>
+            <a:r>
+              <a:rPr lang="en-US" sz="1400" dirty="0">
+                <a:solidFill>
+                  <a:schemeClr val="tx2"/>
+                </a:solidFill>
+              </a:rPr>
+              <a:t>Show state boundaries to check the river's course</a:t>
+            </a:r>
+            <a:endParaRPr lang="en-US" sz="1600" dirty="0"/>
+          </a:p>
+        </p:txBody>
+      </p:sp>
+      <p:sp>
+        <p:nvSpPr>
+          <p:cNvPr id="10" name="Step 3"/>
           <p:cNvSpPr/>
           <p:nvPr/>
         </p:nvSpPr>
         <p:spPr>
           <a:xfrm>
-            <a:off x="6217920" y="1371600"/>
-            <a:ext cx="2514600" cy="1600200"/>
-          </a:xfrm>
-          <a:prstGeom prst="roundRect">
-            <a:avLst>
-              <a:gd name="adj" fmla="val 6857"/>
-            </a:avLst>
+            <a:off x="5715000" y="3200400"/>
+            <a:ext cx="384048" cy="384048"/>
+          </a:xfrm>
+          <a:prstGeom prst="ellipse">
+            <a:avLst/>
           </a:prstGeom>
           <a:solidFill>
-            <a:schemeClr val="bg2"/>
+            <a:schemeClr val="accent1"/>
           </a:solidFill>
           <a:ln/>
         </p:spPr>
       </p:sp>
       <p:sp>
         <p:nvSpPr>
-          <p:cNvPr id="10" name="Text 8"/>
+          <p:cNvPr id="11" name="Text 8"/>
           <p:cNvSpPr txBox="1"/>
           <p:nvPr/>
         </p:nvSpPr>
         <p:spPr>
           <a:xfrm>
-            <a:off x="6400800" y="1508760"/>
-            <a:ext cx="2148840" cy="1325880"/>
+            <a:off x="5715000" y="3200400"/>
+            <a:ext cx="384048" cy="384048"/>
           </a:xfrm>
           <a:prstGeom prst="rect">
             <a:avLst/>
@@ -4035,30 +4143,60 @@
           <a:ln/>
         </p:spPr>
         <p:txBody>
+          <a:bodyPr wrap="square" lIns="0" tIns="0" rIns="0" bIns="0" rtlCol="0" anchor="ctr"/>
+          <a:lstStyle/>
+          <a:p>
+            <a:pPr algn="ctr" indent="0" marL="0">
+              <a:buNone/>
+            </a:pPr>
+            <a:r>
+              <a:rPr lang="en-US" sz="1400" b="1" dirty="0">
+                <a:solidFill>
+                  <a:schemeClr val="bg1"/>
+                </a:solidFill>
+              </a:rPr>
+              <a:t>3</a:t>
+            </a:r>
+            <a:endParaRPr lang="en-US" sz="1400" dirty="0"/>
+          </a:p>
+        </p:txBody>
+      </p:sp>
+      <p:sp>
+        <p:nvSpPr>
+          <p:cNvPr id="12" name="Text 9"/>
+          <p:cNvSpPr txBox="1"/>
+          <p:nvPr/>
+        </p:nvSpPr>
+        <p:spPr>
+          <a:xfrm>
+            <a:off x="6263640" y="3154680"/>
+            <a:ext cx="2468880" cy="868680"/>
+          </a:xfrm>
+          <a:prstGeom prst="rect">
+            <a:avLst/>
+          </a:prstGeom>
+          <a:noFill/>
+          <a:ln/>
+        </p:spPr>
+        <p:txBody>
           <a:bodyPr wrap="square" lIns="0" tIns="0" rIns="0" bIns="0" rtlCol="0" anchor="t"/>
           <a:lstStyle/>
           <a:p>
             <a:pPr indent="0" marL="0">
-              <a:spcAft>
-                <a:spcPts val="400"/>
-              </a:spcAft>
-              <a:buNone/>
-            </a:pPr>
-            <a:r>
-              <a:rPr lang="en-US" sz="1800" b="1" dirty="0">
+              <a:buNone/>
+            </a:pPr>
+            <a:r>
+              <a:rPr lang="en-US" sz="1600" b="1" dirty="0">
                 <a:solidFill>
                   <a:schemeClr val="tx1"/>
                 </a:solidFill>
               </a:rPr>
-              <a:t>Teacher</a:t>
-            </a:r>
-            <a:endParaRPr lang="en-US" sz="1800" dirty="0"/>
+              <a:t>Save for revision</a:t>
+            </a:r>
+            <a:endParaRPr lang="en-US" sz="1600" dirty="0"/>
           </a:p>
           <a:p>
             <a:pPr indent="0" marL="0">
-              <a:spcAft>
-                <a:spcPts val="400"/>
-              </a:spcAft>
               <a:buNone/>
             </a:pPr>
             <a:r>
@@ -4067,79 +4205,7 @@
                   <a:schemeClr val="tx2"/>
                 </a:solidFill>
               </a:rPr>
-              <a:t>Views it at /canvas-image and sends feedback from /teacher-dash</a:t>
-            </a:r>
-            <a:endParaRPr lang="en-US" sz="1800" dirty="0"/>
-          </a:p>
-        </p:txBody>
-      </p:sp>
-      <p:sp>
-        <p:nvSpPr>
-          <p:cNvPr id="11" name="Feedback card"/>
-          <p:cNvSpPr/>
-          <p:nvPr/>
-        </p:nvSpPr>
-        <p:spPr>
-          <a:xfrm>
-            <a:off x="457200" y="3291840"/>
-            <a:ext cx="8229600" cy="1188720"/>
-          </a:xfrm>
-          <a:prstGeom prst="roundRect">
-            <a:avLst>
-              <a:gd name="adj" fmla="val 9231"/>
-            </a:avLst>
-          </a:prstGeom>
-          <a:solidFill>
-            <a:srgbClr val="E8F3FA"/>
-          </a:solidFill>
-          <a:ln/>
-        </p:spPr>
-      </p:sp>
-      <p:sp>
-        <p:nvSpPr>
-          <p:cNvPr id="12" name="Text 10"/>
-          <p:cNvSpPr txBox="1"/>
-          <p:nvPr/>
-        </p:nvSpPr>
-        <p:spPr>
-          <a:xfrm>
-            <a:off x="685800" y="3429000"/>
-            <a:ext cx="7772400" cy="914400"/>
-          </a:xfrm>
-          <a:prstGeom prst="rect">
-            <a:avLst/>
-          </a:prstGeom>
-          <a:noFill/>
-          <a:ln/>
-        </p:spPr>
-        <p:txBody>
-          <a:bodyPr wrap="square" lIns="0" tIns="0" rIns="0" bIns="0" rtlCol="0" anchor="t"/>
-          <a:lstStyle/>
-          <a:p>
-            <a:pPr indent="0" marL="0">
-              <a:buNone/>
-            </a:pPr>
-            <a:r>
-              <a:rPr lang="en-US" sz="1600" b="1" dirty="0">
-                <a:solidFill>
-                  <a:schemeClr val="tx1"/>
-                </a:solidFill>
-              </a:rPr>
-              <a:t>Feedback goes back the other way</a:t>
-            </a:r>
-            <a:endParaRPr lang="en-US" sz="1600" dirty="0"/>
-          </a:p>
-          <a:p>
-            <a:pPr indent="0" marL="0">
-              <a:buNone/>
-            </a:pPr>
-            <a:r>
-              <a:rPr lang="en-US" sz="1400" dirty="0">
-                <a:solidFill>
-                  <a:schemeClr val="tx2"/>
-                </a:solidFill>
-              </a:rPr>
-              <a:t>The teacher's messages go to /send-message. The student page checks /get-messages every 2 seconds and shows each new message as it arrives.</a:t>
+              <a:t>Keep the finished map to revise before the exam</a:t>
             </a:r>
             <a:endParaRPr lang="en-US" sz="1600" dirty="0"/>
           </a:p>
@@ -4247,7 +4313,7 @@
                   <a:schemeClr val="tx1"/>
                 </a:solidFill>
               </a:rPr>
-              <a:t>A simple stack that runs in three commands</a:t>
+              <a:t>Students and teachers stay connected, even online</a:t>
             </a:r>
             <a:endParaRPr lang="en-US" sz="2800" dirty="0"/>
           </a:p>
@@ -4255,83 +4321,13 @@
       </p:sp>
       <p:sp>
         <p:nvSpPr>
-          <p:cNvPr id="3" name="Frontend dot"/>
+          <p:cNvPr id="3" name="Step 1"/>
           <p:cNvSpPr/>
           <p:nvPr/>
         </p:nvSpPr>
         <p:spPr>
           <a:xfrm>
-            <a:off x="457200" y="1325880"/>
-            <a:ext cx="384048" cy="384048"/>
-          </a:xfrm>
-          <a:prstGeom prst="ellipse">
-            <a:avLst/>
-          </a:prstGeom>
-          <a:solidFill>
-            <a:schemeClr val="accent2"/>
-          </a:solidFill>
-          <a:ln/>
-        </p:spPr>
-      </p:sp>
-      <p:sp>
-        <p:nvSpPr>
-          <p:cNvPr id="4" name="Text 2"/>
-          <p:cNvSpPr txBox="1"/>
-          <p:nvPr/>
-        </p:nvSpPr>
-        <p:spPr>
-          <a:xfrm>
-            <a:off x="1005840" y="1280160"/>
-            <a:ext cx="3291840" cy="822960"/>
-          </a:xfrm>
-          <a:prstGeom prst="rect">
-            <a:avLst/>
-          </a:prstGeom>
-          <a:noFill/>
-          <a:ln/>
-        </p:spPr>
-        <p:txBody>
-          <a:bodyPr wrap="square" lIns="0" tIns="0" rIns="0" bIns="0" rtlCol="0" anchor="t"/>
-          <a:lstStyle/>
-          <a:p>
-            <a:pPr indent="0" marL="0">
-              <a:buNone/>
-            </a:pPr>
-            <a:r>
-              <a:rPr lang="en-US" sz="1600" b="1" dirty="0">
-                <a:solidFill>
-                  <a:schemeClr val="tx1"/>
-                </a:solidFill>
-              </a:rPr>
-              <a:t>Frontend</a:t>
-            </a:r>
-            <a:endParaRPr lang="en-US" sz="1600" dirty="0"/>
-          </a:p>
-          <a:p>
-            <a:pPr indent="0" marL="0">
-              <a:buNone/>
-            </a:pPr>
-            <a:r>
-              <a:rPr lang="en-US" sz="1400" dirty="0">
-                <a:solidFill>
-                  <a:schemeClr val="tx2"/>
-                </a:solidFill>
-              </a:rPr>
-              <a:t>HTML, Bootstrap 5, Canvas 2D and inline SVG</a:t>
-            </a:r>
-            <a:endParaRPr lang="en-US" sz="1600" dirty="0"/>
-          </a:p>
-        </p:txBody>
-      </p:sp>
-      <p:sp>
-        <p:nvSpPr>
-          <p:cNvPr id="5" name="Backend dot"/>
-          <p:cNvSpPr/>
-          <p:nvPr/>
-        </p:nvSpPr>
-        <p:spPr>
-          <a:xfrm>
-            <a:off x="457200" y="2286000"/>
+            <a:off x="457200" y="1234440"/>
             <a:ext cx="384048" cy="384048"/>
           </a:xfrm>
           <a:prstGeom prst="ellipse">
@@ -4345,14 +4341,14 @@
       </p:sp>
       <p:sp>
         <p:nvSpPr>
-          <p:cNvPr id="6" name="Text 4"/>
+          <p:cNvPr id="4" name="Text 2"/>
           <p:cNvSpPr txBox="1"/>
           <p:nvPr/>
         </p:nvSpPr>
         <p:spPr>
           <a:xfrm>
-            <a:off x="1005840" y="2240280"/>
-            <a:ext cx="3291840" cy="822960"/>
+            <a:off x="457200" y="1234440"/>
+            <a:ext cx="384048" cy="384048"/>
           </a:xfrm>
           <a:prstGeom prst="rect">
             <a:avLst/>
@@ -4361,6 +4357,42 @@
           <a:ln/>
         </p:spPr>
         <p:txBody>
+          <a:bodyPr wrap="square" lIns="0" tIns="0" rIns="0" bIns="0" rtlCol="0" anchor="ctr"/>
+          <a:lstStyle/>
+          <a:p>
+            <a:pPr algn="ctr" indent="0" marL="0">
+              <a:buNone/>
+            </a:pPr>
+            <a:r>
+              <a:rPr lang="en-US" sz="1400" b="1" dirty="0">
+                <a:solidFill>
+                  <a:schemeClr val="bg1"/>
+                </a:solidFill>
+              </a:rPr>
+              <a:t>1</a:t>
+            </a:r>
+            <a:endParaRPr lang="en-US" sz="1400" dirty="0"/>
+          </a:p>
+        </p:txBody>
+      </p:sp>
+      <p:sp>
+        <p:nvSpPr>
+          <p:cNvPr id="5" name="Text 3"/>
+          <p:cNvSpPr txBox="1"/>
+          <p:nvPr/>
+        </p:nvSpPr>
+        <p:spPr>
+          <a:xfrm>
+            <a:off x="1005840" y="1188720"/>
+            <a:ext cx="2743200" cy="731520"/>
+          </a:xfrm>
+          <a:prstGeom prst="rect">
+            <a:avLst/>
+          </a:prstGeom>
+          <a:noFill/>
+          <a:ln/>
+        </p:spPr>
+        <p:txBody>
           <a:bodyPr wrap="square" lIns="0" tIns="0" rIns="0" bIns="0" rtlCol="0" anchor="t"/>
           <a:lstStyle/>
           <a:p>
@@ -4373,7 +4405,7 @@
                   <a:schemeClr val="tx1"/>
                 </a:solidFill>
               </a:rPr>
-              <a:t>Backend</a:t>
+              <a:t>Student sends the map</a:t>
             </a:r>
             <a:endParaRPr lang="en-US" sz="1600" dirty="0"/>
           </a:p>
@@ -4387,7 +4419,7 @@
                   <a:schemeClr val="tx2"/>
                 </a:solidFill>
               </a:rPr>
-              <a:t>Node.js with Express, CORS and body-parser</a:t>
+              <a:t>One click shares the finished map</a:t>
             </a:r>
             <a:endParaRPr lang="en-US" sz="1600" dirty="0"/>
           </a:p>
@@ -4395,23 +4427,59 @@
       </p:sp>
       <p:sp>
         <p:nvSpPr>
-          <p:cNvPr id="7" name="Data dot"/>
+          <p:cNvPr id="6" name="Step 2"/>
           <p:cNvSpPr/>
           <p:nvPr/>
         </p:nvSpPr>
         <p:spPr>
           <a:xfrm>
-            <a:off x="457200" y="3246120"/>
+            <a:off x="457200" y="2075688"/>
             <a:ext cx="384048" cy="384048"/>
           </a:xfrm>
           <a:prstGeom prst="ellipse">
             <a:avLst/>
           </a:prstGeom>
           <a:solidFill>
-            <a:schemeClr val="accent3"/>
+            <a:schemeClr val="accent1"/>
           </a:solidFill>
           <a:ln/>
         </p:spPr>
+      </p:sp>
+      <p:sp>
+        <p:nvSpPr>
+          <p:cNvPr id="7" name="Text 5"/>
+          <p:cNvSpPr txBox="1"/>
+          <p:nvPr/>
+        </p:nvSpPr>
+        <p:spPr>
+          <a:xfrm>
+            <a:off x="457200" y="2075688"/>
+            <a:ext cx="384048" cy="384048"/>
+          </a:xfrm>
+          <a:prstGeom prst="rect">
+            <a:avLst/>
+          </a:prstGeom>
+          <a:noFill/>
+          <a:ln/>
+        </p:spPr>
+        <p:txBody>
+          <a:bodyPr wrap="square" lIns="0" tIns="0" rIns="0" bIns="0" rtlCol="0" anchor="ctr"/>
+          <a:lstStyle/>
+          <a:p>
+            <a:pPr algn="ctr" indent="0" marL="0">
+              <a:buNone/>
+            </a:pPr>
+            <a:r>
+              <a:rPr lang="en-US" sz="1400" b="1" dirty="0">
+                <a:solidFill>
+                  <a:schemeClr val="bg1"/>
+                </a:solidFill>
+              </a:rPr>
+              <a:t>2</a:t>
+            </a:r>
+            <a:endParaRPr lang="en-US" sz="1400" dirty="0"/>
+          </a:p>
+        </p:txBody>
       </p:sp>
       <p:sp>
         <p:nvSpPr>
@@ -4421,8 +4489,8 @@
         </p:nvSpPr>
         <p:spPr>
           <a:xfrm>
-            <a:off x="1005840" y="3200400"/>
-            <a:ext cx="3291840" cy="822960"/>
+            <a:off x="1005840" y="2029968"/>
+            <a:ext cx="2743200" cy="731520"/>
           </a:xfrm>
           <a:prstGeom prst="rect">
             <a:avLst/>
@@ -4443,7 +4511,7 @@
                   <a:schemeClr val="tx1"/>
                 </a:solidFill>
               </a:rPr>
-              <a:t>Data</a:t>
+              <a:t>Teacher sees it at once</a:t>
             </a:r>
             <a:endParaRPr lang="en-US" sz="1600" dirty="0"/>
           </a:p>
@@ -4457,7 +4525,7 @@
                   <a:schemeClr val="tx2"/>
                 </a:solidFill>
               </a:rPr>
-              <a:t>Files on disk and in-memory messages (MongoDB stubbed in)</a:t>
+              <a:t>No waiting for the next class</a:t>
             </a:r>
             <a:endParaRPr lang="en-US" sz="1600" dirty="0"/>
           </a:p>
@@ -4465,22 +4533,20 @@
       </p:sp>
       <p:sp>
         <p:nvSpPr>
-          <p:cNvPr id="9" name="Terminal"/>
+          <p:cNvPr id="9" name="Step 3"/>
           <p:cNvSpPr/>
           <p:nvPr/>
         </p:nvSpPr>
         <p:spPr>
           <a:xfrm>
-            <a:off x="4663440" y="1280160"/>
-            <a:ext cx="4023360" cy="2651760"/>
-          </a:xfrm>
-          <a:prstGeom prst="roundRect">
-            <a:avLst>
-              <a:gd name="adj" fmla="val 4138"/>
-            </a:avLst>
+            <a:off x="457200" y="2916936"/>
+            <a:ext cx="384048" cy="384048"/>
+          </a:xfrm>
+          <a:prstGeom prst="ellipse">
+            <a:avLst/>
           </a:prstGeom>
           <a:solidFill>
-            <a:schemeClr val="tx1"/>
+            <a:schemeClr val="accent1"/>
           </a:solidFill>
           <a:ln/>
         </p:spPr>
@@ -4493,8 +4559,8 @@
         </p:nvSpPr>
         <p:spPr>
           <a:xfrm>
-            <a:off x="4937760" y="1463040"/>
-            <a:ext cx="3566160" cy="2286000"/>
+            <a:off x="457200" y="2916936"/>
+            <a:ext cx="384048" cy="384048"/>
           </a:xfrm>
           <a:prstGeom prst="rect">
             <a:avLst/>
@@ -4503,107 +4569,21 @@
           <a:ln/>
         </p:spPr>
         <p:txBody>
-          <a:bodyPr wrap="square" lIns="0" tIns="0" rIns="0" bIns="0" rtlCol="0" anchor="t"/>
-          <a:lstStyle/>
-          <a:p>
-            <a:pPr indent="0" marL="0">
-              <a:spcAft>
-                <a:spcPts val="600"/>
-              </a:spcAft>
-              <a:buNone/>
-            </a:pPr>
-            <a:r>
-              <a:rPr lang="en-US" sz="1600" dirty="0">
+          <a:bodyPr wrap="square" lIns="0" tIns="0" rIns="0" bIns="0" rtlCol="0" anchor="ctr"/>
+          <a:lstStyle/>
+          <a:p>
+            <a:pPr algn="ctr" indent="0" marL="0">
+              <a:buNone/>
+            </a:pPr>
+            <a:r>
+              <a:rPr lang="en-US" sz="1400" b="1" dirty="0">
                 <a:solidFill>
                   <a:schemeClr val="bg1"/>
                 </a:solidFill>
-                <a:latin typeface="Courier New" pitchFamily="34" charset="0"/>
-                <a:ea typeface="Courier New" pitchFamily="34" charset="-122"/>
-                <a:cs typeface="Courier New" pitchFamily="34" charset="-120"/>
-              </a:rPr>
-              <a:t>$ cd annotate</a:t>
-            </a:r>
-            <a:endParaRPr lang="en-US" sz="1600" dirty="0"/>
-          </a:p>
-          <a:p>
-            <a:pPr indent="0" marL="0">
-              <a:spcAft>
-                <a:spcPts val="600"/>
-              </a:spcAft>
-              <a:buNone/>
-            </a:pPr>
-            <a:r>
-              <a:rPr lang="en-US" sz="1600" dirty="0">
-                <a:solidFill>
-                  <a:schemeClr val="bg1"/>
-                </a:solidFill>
-                <a:latin typeface="Courier New" pitchFamily="34" charset="0"/>
-                <a:ea typeface="Courier New" pitchFamily="34" charset="-122"/>
-                <a:cs typeface="Courier New" pitchFamily="34" charset="-120"/>
-              </a:rPr>
-              <a:t>$ npm install</a:t>
-            </a:r>
-            <a:endParaRPr lang="en-US" sz="1600" dirty="0"/>
-          </a:p>
-          <a:p>
-            <a:pPr indent="0" marL="0">
-              <a:spcAft>
-                <a:spcPts val="600"/>
-              </a:spcAft>
-              <a:buNone/>
-            </a:pPr>
-            <a:r>
-              <a:rPr lang="en-US" sz="1600" dirty="0">
-                <a:solidFill>
-                  <a:schemeClr val="bg1"/>
-                </a:solidFill>
-                <a:latin typeface="Courier New" pitchFamily="34" charset="0"/>
-                <a:ea typeface="Courier New" pitchFamily="34" charset="-122"/>
-                <a:cs typeface="Courier New" pitchFamily="34" charset="-120"/>
-              </a:rPr>
-              <a:t>$ node app.js</a:t>
-            </a:r>
-            <a:endParaRPr lang="en-US" sz="1600" dirty="0"/>
-          </a:p>
-          <a:p>
-            <a:pPr indent="0" marL="0">
-              <a:spcAft>
-                <a:spcPts val="600"/>
-              </a:spcAft>
-              <a:buNone/>
-            </a:pPr>
-            <a:r>
-              <a:rPr lang="en-US" sz="1600" dirty="0">
-                <a:solidFill>
-                  <a:schemeClr val="bg1"/>
-                </a:solidFill>
-                <a:latin typeface="Courier New" pitchFamily="34" charset="0"/>
-                <a:ea typeface="Courier New" pitchFamily="34" charset="-122"/>
-                <a:cs typeface="Courier New" pitchFamily="34" charset="-120"/>
-              </a:rPr>
-              <a:t> </a:t>
-            </a:r>
-            <a:endParaRPr lang="en-US" sz="1600" dirty="0"/>
-          </a:p>
-          <a:p>
-            <a:pPr indent="0" marL="0">
-              <a:spcAft>
-                <a:spcPts val="600"/>
-              </a:spcAft>
-              <a:buNone/>
-            </a:pPr>
-            <a:r>
-              <a:rPr lang="en-US" sz="1600" dirty="0">
-                <a:solidFill>
-                  <a:schemeClr val="accent5"/>
-                </a:solidFill>
-                <a:latin typeface="Courier New" pitchFamily="34" charset="0"/>
-                <a:ea typeface="Courier New" pitchFamily="34" charset="-122"/>
-                <a:cs typeface="Courier New" pitchFamily="34" charset="-120"/>
-              </a:rPr>
-              <a:t>Open :3001/Terrateach</a:t>
-            </a:r>
-            <a:endParaRPr lang="en-US" sz="1600" dirty="0"/>
+              </a:rPr>
+              <a:t>3</a:t>
+            </a:r>
+            <a:endParaRPr lang="en-US" sz="1400" dirty="0"/>
           </a:p>
         </p:txBody>
       </p:sp>
@@ -4615,8 +4595,8 @@
         </p:nvSpPr>
         <p:spPr>
           <a:xfrm>
-            <a:off x="4663440" y="4069080"/>
-            <a:ext cx="4023360" cy="365760"/>
+            <a:off x="1005840" y="2871216"/>
+            <a:ext cx="2743200" cy="731520"/>
           </a:xfrm>
           <a:prstGeom prst="rect">
             <a:avLst/>
@@ -4625,21 +4605,208 @@
           <a:ln/>
         </p:spPr>
         <p:txBody>
+          <a:bodyPr wrap="square" lIns="0" tIns="0" rIns="0" bIns="0" rtlCol="0" anchor="t"/>
+          <a:lstStyle/>
+          <a:p>
+            <a:pPr indent="0" marL="0">
+              <a:buNone/>
+            </a:pPr>
+            <a:r>
+              <a:rPr lang="en-US" sz="1600" b="1" dirty="0">
+                <a:solidFill>
+                  <a:schemeClr val="tx1"/>
+                </a:solidFill>
+              </a:rPr>
+              <a:t>Teacher replies</a:t>
+            </a:r>
+            <a:endParaRPr lang="en-US" sz="1600" dirty="0"/>
+          </a:p>
+          <a:p>
+            <a:pPr indent="0" marL="0">
+              <a:buNone/>
+            </a:pPr>
+            <a:r>
+              <a:rPr lang="en-US" sz="1400" dirty="0">
+                <a:solidFill>
+                  <a:schemeClr val="tx2"/>
+                </a:solidFill>
+              </a:rPr>
+              <a:t>Short notes, like “Now add the Yamuna”</a:t>
+            </a:r>
+            <a:endParaRPr lang="en-US" sz="1600" dirty="0"/>
+          </a:p>
+        </p:txBody>
+      </p:sp>
+      <p:sp>
+        <p:nvSpPr>
+          <p:cNvPr id="12" name="Step 4"/>
+          <p:cNvSpPr/>
+          <p:nvPr/>
+        </p:nvSpPr>
+        <p:spPr>
+          <a:xfrm>
+            <a:off x="457200" y="3758184"/>
+            <a:ext cx="384048" cy="384048"/>
+          </a:xfrm>
+          <a:prstGeom prst="ellipse">
+            <a:avLst/>
+          </a:prstGeom>
+          <a:solidFill>
+            <a:schemeClr val="accent1"/>
+          </a:solidFill>
+          <a:ln/>
+        </p:spPr>
+      </p:sp>
+      <p:sp>
+        <p:nvSpPr>
+          <p:cNvPr id="13" name="Text 11"/>
+          <p:cNvSpPr txBox="1"/>
+          <p:nvPr/>
+        </p:nvSpPr>
+        <p:spPr>
+          <a:xfrm>
+            <a:off x="457200" y="3758184"/>
+            <a:ext cx="384048" cy="384048"/>
+          </a:xfrm>
+          <a:prstGeom prst="rect">
+            <a:avLst/>
+          </a:prstGeom>
+          <a:noFill/>
+          <a:ln/>
+        </p:spPr>
+        <p:txBody>
           <a:bodyPr wrap="square" lIns="0" tIns="0" rIns="0" bIns="0" rtlCol="0" anchor="ctr"/>
           <a:lstStyle/>
           <a:p>
+            <a:pPr algn="ctr" indent="0" marL="0">
+              <a:buNone/>
+            </a:pPr>
+            <a:r>
+              <a:rPr lang="en-US" sz="1400" b="1" dirty="0">
+                <a:solidFill>
+                  <a:schemeClr val="bg1"/>
+                </a:solidFill>
+              </a:rPr>
+              <a:t>4</a:t>
+            </a:r>
+            <a:endParaRPr lang="en-US" sz="1400" dirty="0"/>
+          </a:p>
+        </p:txBody>
+      </p:sp>
+      <p:sp>
+        <p:nvSpPr>
+          <p:cNvPr id="14" name="Text 12"/>
+          <p:cNvSpPr txBox="1"/>
+          <p:nvPr/>
+        </p:nvSpPr>
+        <p:spPr>
+          <a:xfrm>
+            <a:off x="1005840" y="3712464"/>
+            <a:ext cx="2743200" cy="731520"/>
+          </a:xfrm>
+          <a:prstGeom prst="rect">
+            <a:avLst/>
+          </a:prstGeom>
+          <a:noFill/>
+          <a:ln/>
+        </p:spPr>
+        <p:txBody>
+          <a:bodyPr wrap="square" lIns="0" tIns="0" rIns="0" bIns="0" rtlCol="0" anchor="t"/>
+          <a:lstStyle/>
+          <a:p>
             <a:pPr indent="0" marL="0">
               <a:buNone/>
             </a:pPr>
             <a:r>
-              <a:rPr lang="en-US" sz="1200" i="1" dirty="0">
+              <a:rPr lang="en-US" sz="1600" b="1" dirty="0">
+                <a:solidFill>
+                  <a:schemeClr val="tx1"/>
+                </a:solidFill>
+              </a:rPr>
+              <a:t>Student reads the feedback</a:t>
+            </a:r>
+            <a:endParaRPr lang="en-US" sz="1600" dirty="0"/>
+          </a:p>
+          <a:p>
+            <a:pPr indent="0" marL="0">
+              <a:buNone/>
+            </a:pPr>
+            <a:r>
+              <a:rPr lang="en-US" sz="1400" dirty="0">
+                <a:solidFill>
+                  <a:schemeClr val="tx2"/>
+                </a:solidFill>
+              </a:rPr>
+              <a:t>It appears on their screen within seconds</a:t>
+            </a:r>
+            <a:endParaRPr lang="en-US" sz="1600" dirty="0"/>
+          </a:p>
+        </p:txBody>
+      </p:sp>
+      <p:pic>
+        <p:nvPicPr>
+          <p:cNvPr id="15" name="Screenshot" descr="teacher.jpg">    </p:cNvPr>
+          <p:cNvPicPr>
+            <a:picLocks noChangeAspect="1"/>
+          </p:cNvPicPr>
+          <p:nvPr/>
+        </p:nvPicPr>
+        <p:blipFill>
+          <a:blip r:embed="rId1"/>
+          <a:stretch>
+            <a:fillRect/>
+          </a:stretch>
+        </p:blipFill>
+        <p:spPr>
+          <a:xfrm>
+            <a:off x="3931920" y="1234440"/>
+            <a:ext cx="4754880" cy="2674620"/>
+          </a:xfrm>
+          <a:prstGeom prst="rect">
+            <a:avLst/>
+          </a:prstGeom>
+          <a:effectLst>
+            <a:outerShdw sx="100000" sy="100000" kx="0" ky="0" algn="bl" rotWithShape="0" blurRad="101600" dist="25400" dir="5400000">
+              <a:srgbClr val="000000">
+                <a:alpha val="18000"/>
+              </a:srgbClr>
+            </a:outerShdw>
+          </a:effectLst>
+        </p:spPr>
+      </p:pic>
+      <p:sp>
+        <p:nvSpPr>
+          <p:cNvPr id="16" name="Text 13"/>
+          <p:cNvSpPr txBox="1"/>
+          <p:nvPr/>
+        </p:nvSpPr>
+        <p:spPr>
+          <a:xfrm>
+            <a:off x="3931920" y="4023360"/>
+            <a:ext cx="4754880" cy="320040"/>
+          </a:xfrm>
+          <a:prstGeom prst="rect">
+            <a:avLst/>
+          </a:prstGeom>
+          <a:noFill/>
+          <a:ln/>
+        </p:spPr>
+        <p:txBody>
+          <a:bodyPr wrap="square" lIns="0" tIns="0" rIns="0" bIns="0" rtlCol="0" anchor="ctr"/>
+          <a:lstStyle/>
+          <a:p>
+            <a:pPr indent="0" marL="0">
+              <a:buNone/>
+            </a:pPr>
+            <a:r>
+              <a:rPr lang="en-US" sz="1100" i="1" dirty="0">
                 <a:solidFill>
                   <a:srgbClr val="8A7F76"/>
                 </a:solidFill>
               </a:rPr>
-              <a:t>Desktop browsers only, because the map uses fixed pixel positions</a:t>
-            </a:r>
-            <a:endParaRPr lang="en-US" sz="1200" dirty="0"/>
+              <a:t>What the teacher sees: the student's map and the feedback they sent</a:t>
+            </a:r>
+            <a:endParaRPr lang="en-US" sz="1100" dirty="0"/>
           </a:p>
         </p:txBody>
       </p:sp>
@@ -4716,13 +4883,73 @@
       <p:sp>
         <p:nvSpPr>
           <p:cNvPr id="2" name="Text 0"/>
+          <p:cNvSpPr/>
+          <p:nvPr>
+            <p:ph idx="100" type="title" hasCustomPrompt="1"/>
+          </p:nvPr>
+        </p:nvSpPr>
+        <p:spPr>
+          <a:xfrm>
+            <a:off x="457200" y="274320"/>
+            <a:ext cx="8229600" cy="685800"/>
+          </a:xfrm>
+          <a:prstGeom prst="rect">
+            <a:avLst/>
+          </a:prstGeom>
+          <a:noFill/>
+          <a:ln/>
+        </p:spPr>
+        <p:txBody>
+          <a:bodyPr wrap="square" lIns="0" tIns="0" rIns="0" bIns="0" rtlCol="0" anchor="ctr"/>
+          <a:lstStyle/>
+          <a:p>
+            <a:pPr algn="l" indent="0" marL="0">
+              <a:buNone/>
+            </a:pPr>
+            <a:r>
+              <a:rPr lang="en-US" sz="2800" b="1" dirty="0">
+                <a:solidFill>
+                  <a:schemeClr val="tx1"/>
+                </a:solidFill>
+              </a:rPr>
+              <a:t>What changes for students</a:t>
+            </a:r>
+            <a:endParaRPr lang="en-US" sz="2800" dirty="0"/>
+          </a:p>
+        </p:txBody>
+      </p:sp>
+      <p:sp>
+        <p:nvSpPr>
+          <p:cNvPr id="3" name="Before"/>
+          <p:cNvSpPr/>
+          <p:nvPr/>
+        </p:nvSpPr>
+        <p:spPr>
+          <a:xfrm>
+            <a:off x="457200" y="1234440"/>
+            <a:ext cx="4023360" cy="3200400"/>
+          </a:xfrm>
+          <a:prstGeom prst="roundRect">
+            <a:avLst>
+              <a:gd name="adj" fmla="val 3429"/>
+            </a:avLst>
+          </a:prstGeom>
+          <a:solidFill>
+            <a:schemeClr val="bg2"/>
+          </a:solidFill>
+          <a:ln/>
+        </p:spPr>
+      </p:sp>
+      <p:sp>
+        <p:nvSpPr>
+          <p:cNvPr id="4" name="Text 2"/>
           <p:cNvSpPr txBox="1"/>
           <p:nvPr/>
         </p:nvSpPr>
         <p:spPr>
           <a:xfrm>
-            <a:off x="548640" y="411480"/>
-            <a:ext cx="8046720" cy="731520"/>
+            <a:off x="777240" y="1463040"/>
+            <a:ext cx="3383280" cy="457200"/>
           </a:xfrm>
           <a:prstGeom prst="rect">
             <a:avLst/>
@@ -4738,14 +4965,336 @@
               <a:buNone/>
             </a:pPr>
             <a:r>
-              <a:rPr lang="en-US" sz="3600" b="1" dirty="0">
-                <a:solidFill>
-                  <a:schemeClr val="bg1"/>
+              <a:rPr lang="en-US" sz="2000" b="1" dirty="0">
+                <a:solidFill>
+                  <a:schemeClr val="tx1"/>
                 </a:solidFill>
                 <a:latin typeface="Cambria" pitchFamily="34" charset="0"/>
                 <a:ea typeface="Cambria" pitchFamily="34" charset="-122"/>
                 <a:cs typeface="Cambria" pitchFamily="34" charset="-120"/>
               </a:rPr>
+              <a:t>Before</a:t>
+            </a:r>
+            <a:endParaRPr lang="en-US" sz="2000" dirty="0"/>
+          </a:p>
+        </p:txBody>
+      </p:sp>
+      <p:sp>
+        <p:nvSpPr>
+          <p:cNvPr id="5" name="Text 3"/>
+          <p:cNvSpPr txBox="1"/>
+          <p:nvPr/>
+        </p:nvSpPr>
+        <p:spPr>
+          <a:xfrm>
+            <a:off x="777240" y="2103120"/>
+            <a:ext cx="3383280" cy="2103120"/>
+          </a:xfrm>
+          <a:prstGeom prst="rect">
+            <a:avLst/>
+          </a:prstGeom>
+          <a:noFill/>
+          <a:ln/>
+        </p:spPr>
+        <p:txBody>
+          <a:bodyPr wrap="square" lIns="0" tIns="0" rIns="0" bIns="0" rtlCol="0" anchor="t"/>
+          <a:lstStyle/>
+          <a:p>
+            <a:pPr marL="342900" indent="-342900">
+              <a:spcAft>
+                <a:spcPts val="1200"/>
+              </a:spcAft>
+              <a:buSzPct val="100000"/>
+              <a:buChar char="•"/>
+            </a:pPr>
+            <a:r>
+              <a:rPr lang="en-US" sz="1600" dirty="0">
+                <a:solidFill>
+                  <a:schemeClr val="tx2"/>
+                </a:solidFill>
+              </a:rPr>
+              <a:t>Unsure whether their map was right</a:t>
+            </a:r>
+            <a:endParaRPr lang="en-US" sz="1600" dirty="0"/>
+          </a:p>
+          <a:p>
+            <a:pPr marL="342900" indent="-342900">
+              <a:spcAft>
+                <a:spcPts val="1200"/>
+              </a:spcAft>
+              <a:buSzPct val="100000"/>
+              <a:buChar char="•"/>
+            </a:pPr>
+            <a:r>
+              <a:rPr lang="en-US" sz="1600" dirty="0">
+                <a:solidFill>
+                  <a:schemeClr val="tx2"/>
+                </a:solidFill>
+              </a:rPr>
+              <a:t>Waited for the next class to ask a question</a:t>
+            </a:r>
+            <a:endParaRPr lang="en-US" sz="1600" dirty="0"/>
+          </a:p>
+          <a:p>
+            <a:pPr marL="342900" indent="-342900">
+              <a:spcAft>
+                <a:spcPts val="1200"/>
+              </a:spcAft>
+              <a:buSzPct val="100000"/>
+              <a:buChar char="•"/>
+            </a:pPr>
+            <a:r>
+              <a:rPr lang="en-US" sz="1600" dirty="0">
+                <a:solidFill>
+                  <a:schemeClr val="tx2"/>
+                </a:solidFill>
+              </a:rPr>
+              <a:t>Learned from maps that differ from the exam</a:t>
+            </a:r>
+            <a:endParaRPr lang="en-US" sz="1600" dirty="0"/>
+          </a:p>
+        </p:txBody>
+      </p:sp>
+      <p:sp>
+        <p:nvSpPr>
+          <p:cNvPr id="6" name="With TerraTeach"/>
+          <p:cNvSpPr/>
+          <p:nvPr/>
+        </p:nvSpPr>
+        <p:spPr>
+          <a:xfrm>
+            <a:off x="4663440" y="1234440"/>
+            <a:ext cx="4023360" cy="3200400"/>
+          </a:xfrm>
+          <a:prstGeom prst="roundRect">
+            <a:avLst>
+              <a:gd name="adj" fmla="val 3429"/>
+            </a:avLst>
+          </a:prstGeom>
+          <a:solidFill>
+            <a:schemeClr val="tx1"/>
+          </a:solidFill>
+          <a:ln/>
+        </p:spPr>
+      </p:sp>
+      <p:sp>
+        <p:nvSpPr>
+          <p:cNvPr id="7" name="Text 5"/>
+          <p:cNvSpPr txBox="1"/>
+          <p:nvPr/>
+        </p:nvSpPr>
+        <p:spPr>
+          <a:xfrm>
+            <a:off x="4983480" y="1463040"/>
+            <a:ext cx="3383280" cy="457200"/>
+          </a:xfrm>
+          <a:prstGeom prst="rect">
+            <a:avLst/>
+          </a:prstGeom>
+          <a:noFill/>
+          <a:ln/>
+        </p:spPr>
+        <p:txBody>
+          <a:bodyPr wrap="square" lIns="0" tIns="0" rIns="0" bIns="0" rtlCol="0" anchor="ctr"/>
+          <a:lstStyle/>
+          <a:p>
+            <a:pPr indent="0" marL="0">
+              <a:buNone/>
+            </a:pPr>
+            <a:r>
+              <a:rPr lang="en-US" sz="2000" b="1" dirty="0">
+                <a:solidFill>
+                  <a:schemeClr val="accent5"/>
+                </a:solidFill>
+                <a:latin typeface="Cambria" pitchFamily="34" charset="0"/>
+                <a:ea typeface="Cambria" pitchFamily="34" charset="-122"/>
+                <a:cs typeface="Cambria" pitchFamily="34" charset="-120"/>
+              </a:rPr>
+              <a:t>With TerraTeach</a:t>
+            </a:r>
+            <a:endParaRPr lang="en-US" sz="2000" dirty="0"/>
+          </a:p>
+        </p:txBody>
+      </p:sp>
+      <p:sp>
+        <p:nvSpPr>
+          <p:cNvPr id="8" name="Text 6"/>
+          <p:cNvSpPr txBox="1"/>
+          <p:nvPr/>
+        </p:nvSpPr>
+        <p:spPr>
+          <a:xfrm>
+            <a:off x="4983480" y="2103120"/>
+            <a:ext cx="3383280" cy="2103120"/>
+          </a:xfrm>
+          <a:prstGeom prst="rect">
+            <a:avLst/>
+          </a:prstGeom>
+          <a:noFill/>
+          <a:ln/>
+        </p:spPr>
+        <p:txBody>
+          <a:bodyPr wrap="square" lIns="0" tIns="0" rIns="0" bIns="0" rtlCol="0" anchor="t"/>
+          <a:lstStyle/>
+          <a:p>
+            <a:pPr marL="342900" indent="-342900">
+              <a:spcAft>
+                <a:spcPts val="1200"/>
+              </a:spcAft>
+              <a:buSzPct val="100000"/>
+              <a:buChar char="•"/>
+            </a:pPr>
+            <a:r>
+              <a:rPr lang="en-US" sz="1600" dirty="0">
+                <a:solidFill>
+                  <a:schemeClr val="bg1"/>
+                </a:solidFill>
+              </a:rPr>
+              <a:t>A correct answer map for every river</a:t>
+            </a:r>
+            <a:endParaRPr lang="en-US" sz="1600" dirty="0"/>
+          </a:p>
+          <a:p>
+            <a:pPr marL="342900" indent="-342900">
+              <a:spcAft>
+                <a:spcPts val="1200"/>
+              </a:spcAft>
+              <a:buSzPct val="100000"/>
+              <a:buChar char="•"/>
+            </a:pPr>
+            <a:r>
+              <a:rPr lang="en-US" sz="1600" dirty="0">
+                <a:solidFill>
+                  <a:schemeClr val="bg1"/>
+                </a:solidFill>
+              </a:rPr>
+              <a:t>Quick feedback from the teacher, even online</a:t>
+            </a:r>
+            <a:endParaRPr lang="en-US" sz="1600" dirty="0"/>
+          </a:p>
+          <a:p>
+            <a:pPr marL="342900" indent="-342900">
+              <a:spcAft>
+                <a:spcPts val="1200"/>
+              </a:spcAft>
+              <a:buSzPct val="100000"/>
+              <a:buChar char="•"/>
+            </a:pPr>
+            <a:r>
+              <a:rPr lang="en-US" sz="1600" dirty="0">
+                <a:solidFill>
+                  <a:schemeClr val="bg1"/>
+                </a:solidFill>
+              </a:rPr>
+              <a:t>Practice that matches the exam paper</a:t>
+            </a:r>
+            <a:endParaRPr lang="en-US" sz="1600" dirty="0"/>
+          </a:p>
+        </p:txBody>
+      </p:sp>
+      <p:sp>
+        <p:nvSpPr>
+          <p:cNvPr id="25" name="Slide Number Placeholder 0"/>
+          <p:cNvSpPr>
+            <a:spLocks noGrp="1"/>
+          </p:cNvSpPr>
+          <p:nvPr>
+            <p:ph type="sldNum" sz="quarter" idx="4294967295"/>
+          </p:nvPr>
+        </p:nvSpPr>
+        <p:spPr>
+          <a:xfrm>
+            <a:off x="8412480" y="4754880"/>
+            <a:ext cx="365760" cy="228600"/>
+          </a:xfrm>
+          <a:prstGeom prst="rect">
+            <a:avLst/>
+          </a:prstGeom>
+          <a:extLst>
+            <a:ext uri="{C572A759-6A51-4108-AA02-DFA0A04FC94B}">
+              <ma14:wrappingTextBoxFlag xmlns:ma14="http://schemas.microsoft.com/office/mac/drawingml/2011/main" val="0"/>
+            </a:ext>
+          </a:extLst>
+        </p:spPr>
+        <p:txBody>
+          <a:bodyPr/>
+          <a:lstStyle>
+            <a:lvl1pPr>
+              <a:defRPr sz="1000">
+                <a:solidFill>
+                  <a:srgbClr val="8A7F76"/>
+                </a:solidFill>
+              </a:defRPr>
+            </a:lvl1pPr>
+          </a:lstStyle>
+          <a:p>
+            <a:pPr algn="r"/>
+            <a:fld id="{F7021451-1387-4CA6-816F-3879F97B5CBC}" type="slidenum">
+              <a:rPr b="0" lang="en-US"/>
+              <a:t>8</a:t>
+            </a:fld>
+            <a:endParaRPr lang="en-US"/>
+          </a:p>
+        </p:txBody>
+      </p:sp>
+    </p:spTree>
+  </p:cSld>
+  <p:clrMapOvr>
+    <a:masterClrMapping/>
+  </p:clrMapOvr>
+</p:sld>
+</file>
+
+<file path=ppt/slides/slide9.xml><?xml version="1.0" encoding="utf-8"?>
+<p:sld xmlns:a="http://schemas.openxmlformats.org/drawingml/2006/main" xmlns:r="http://schemas.openxmlformats.org/officeDocument/2006/relationships" xmlns:p="http://schemas.openxmlformats.org/presentationml/2006/main">
+  <p:cSld name="Slide 9">
+    <p:spTree>
+      <p:nvGrpSpPr>
+        <p:cNvPr id="1" name=""/>
+        <p:cNvGrpSpPr/>
+        <p:nvPr/>
+      </p:nvGrpSpPr>
+      <p:grpSpPr>
+        <a:xfrm>
+          <a:off x="0" y="0"/>
+          <a:ext cx="0" cy="0"/>
+          <a:chOff x="0" y="0"/>
+          <a:chExt cx="0" cy="0"/>
+        </a:xfrm>
+      </p:grpSpPr>
+      <p:sp>
+        <p:nvSpPr>
+          <p:cNvPr id="2" name="Text 0"/>
+          <p:cNvSpPr txBox="1"/>
+          <p:nvPr/>
+        </p:nvSpPr>
+        <p:spPr>
+          <a:xfrm>
+            <a:off x="548640" y="411480"/>
+            <a:ext cx="8046720" cy="731520"/>
+          </a:xfrm>
+          <a:prstGeom prst="rect">
+            <a:avLst/>
+          </a:prstGeom>
+          <a:noFill/>
+          <a:ln/>
+        </p:spPr>
+        <p:txBody>
+          <a:bodyPr wrap="square" lIns="0" tIns="0" rIns="0" bIns="0" rtlCol="0" anchor="ctr"/>
+          <a:lstStyle/>
+          <a:p>
+            <a:pPr indent="0" marL="0">
+              <a:buNone/>
+            </a:pPr>
+            <a:r>
+              <a:rPr lang="en-US" sz="3600" b="1" dirty="0">
+                <a:solidFill>
+                  <a:schemeClr val="bg1"/>
+                </a:solidFill>
+                <a:latin typeface="Cambria" pitchFamily="34" charset="0"/>
+                <a:ea typeface="Cambria" pitchFamily="34" charset="-122"/>
+                <a:cs typeface="Cambria" pitchFamily="34" charset="-120"/>
+              </a:rPr>
               <a:t>What comes next</a:t>
             </a:r>
             <a:endParaRPr lang="en-US" sz="3600" dirty="0"/>
@@ -4754,7 +5303,7 @@
       </p:sp>
       <p:sp>
         <p:nvSpPr>
-          <p:cNvPr id="3" name="Classrooms"/>
+          <p:cNvPr id="3" name="Virtual classrooms"/>
           <p:cNvSpPr/>
           <p:nvPr/>
         </p:nvSpPr>
@@ -4807,7 +5356,7 @@
                   <a:schemeClr val="accent5"/>
                 </a:solidFill>
               </a:rPr>
-              <a:t>Classrooms</a:t>
+              <a:t>Virtual classrooms</a:t>
             </a:r>
             <a:endParaRPr lang="en-US" sz="1800" dirty="0"/>
           </a:p>
@@ -4824,7 +5373,7 @@
                   <a:schemeClr val="bg1"/>
                 </a:solidFill>
               </a:rPr>
-              <a:t>Make “Join a room” real, with a separate space for each class</a:t>
+              <a:t>A room for each class, so teachers can follow every student</a:t>
             </a:r>
             <a:endParaRPr lang="en-US" sz="1800" dirty="0"/>
           </a:p>
@@ -4832,7 +5381,7 @@
       </p:sp>
       <p:sp>
         <p:nvSpPr>
-          <p:cNvPr id="5" name="Persistence"/>
+          <p:cNvPr id="5" name="More exam maps"/>
           <p:cNvSpPr/>
           <p:nvPr/>
         </p:nvSpPr>
@@ -4885,7 +5434,7 @@
                   <a:schemeClr val="accent5"/>
                 </a:solidFill>
               </a:rPr>
-              <a:t>Persistence</a:t>
+              <a:t>More exam maps</a:t>
             </a:r>
             <a:endParaRPr lang="en-US" sz="1800" dirty="0"/>
           </a:p>
@@ -4902,7 +5451,7 @@
                   <a:schemeClr val="bg1"/>
                 </a:solidFill>
               </a:rPr>
-              <a:t>Turn on MongoDB and give each student their own submission file, instead of overwriting canvasData.png</a:t>
+              <a:t>Mountains, soils, states and every river in practice mode</a:t>
             </a:r>
             <a:endParaRPr lang="en-US" sz="1800" dirty="0"/>
           </a:p>
@@ -4910,7 +5459,7 @@
       </p:sp>
       <p:sp>
         <p:nvSpPr>
-          <p:cNvPr id="7" name="More maps"/>
+          <p:cNvPr id="7" name="Any device"/>
           <p:cNvSpPr/>
           <p:nvPr/>
         </p:nvSpPr>
@@ -4963,7 +5512,7 @@
                   <a:schemeClr val="accent5"/>
                 </a:solidFill>
               </a:rPr>
-              <a:t>More maps</a:t>
+              <a:t>Any device</a:t>
             </a:r>
             <a:endParaRPr lang="en-US" sz="1800" dirty="0"/>
           </a:p>
@@ -4980,7 +5529,7 @@
                   <a:schemeClr val="bg1"/>
                 </a:solidFill>
               </a:rPr>
-              <a:t>Mountains, soils and states, plus the remaining rivers in Test Yourself</a:t>
+              <a:t>Use TerraTeach on tablets and phones, not just computers</a:t>
             </a:r>
             <a:endParaRPr lang="en-US" sz="1800" dirty="0"/>
           </a:p>
@@ -4988,7 +5537,7 @@
       </p:sp>
       <p:sp>
         <p:nvSpPr>
-          <p:cNvPr id="9" name="Wider reach"/>
+          <p:cNvPr id="9" name="Progress tracking"/>
           <p:cNvSpPr/>
           <p:nvPr/>
         </p:nvSpPr>
@@ -5041,7 +5590,7 @@
                   <a:schemeClr val="accent5"/>
                 </a:solidFill>
               </a:rPr>
-              <a:t>Wider reach</a:t>
+              <a:t>Progress tracking</a:t>
             </a:r>
             <a:endParaRPr lang="en-US" sz="1800" dirty="0"/>
           </a:p>
@@ -5058,7 +5607,7 @@
                   <a:schemeClr val="bg1"/>
                 </a:solidFill>
               </a:rPr>
-              <a:t>Responsive canvas for tablets, and fixed asset paths on the /Terrateach/student route</a:t>
+              <a:t>Show teachers which maps each student finds hardest</a:t>
             </a:r>
             <a:endParaRPr lang="en-US" sz="1800" dirty="0"/>
           </a:p>

</xml_diff>

<commit_message>
Remove open-source closing from video; clarify that the states map shows river context
Co-Authored-By: Claude Opus 5.5 <noreply@anthropic.com>
Claude-Session: https://claude.ai/code/session_019gPhNF3CE9nwEznmCvTmpj
</commit_message>
<xml_diff>
--- a/docs/TerraTeach.pptx
+++ b/docs/TerraTeach.pptx
@@ -115,13 +115,13 @@
   <p:extLst>
     <p:ext uri="{521415D9-36F7-43E2-AB2F-B90AF26B5E84}">
       <p14:sectionLst xmlns:p14="http://schemas.microsoft.com/office/powerpoint/2010/main">
-        <p14:section name="The problem" id="{a9036d2d-0e1e-25da-2017-b93ae07c2a45}">
+        <p14:section name="The problem" id="{4fd19769-04fb-999d-0632-006ca0392219}">
           <p14:sldIdLst>
             <p14:sldId id="256"/>
             <p14:sldId id="257"/>
           </p14:sldIdLst>
         </p14:section>
-        <p14:section name="Our solution" id="{1824728b-23e6-06e3-0a06-b075d270d585}">
+        <p14:section name="Our solution" id="{daeb3ecf-1f80-97ad-fe24-7a1a95649968}">
           <p14:sldIdLst>
             <p14:sldId id="258"/>
             <p14:sldId id="259"/>
@@ -130,12 +130,12 @@
             <p14:sldId id="262"/>
           </p14:sldIdLst>
         </p14:section>
-        <p14:section name="Impact" id="{abb3cd7c-9ee3-e5c5-c8fd-cb4dad246a27}">
+        <p14:section name="Impact" id="{4ec43577-c6b5-edb2-acb4-1e2a08ddab78}">
           <p14:sldIdLst>
             <p14:sldId id="263"/>
           </p14:sldIdLst>
         </p14:section>
-        <p14:section name="Next steps" id="{805b7f4d-d337-ce5a-82ba-d5048a8726bb}">
+        <p14:section name="Next steps" id="{3be1ffce-10bc-419b-5fd6-e3a0949a79bd}">
           <p14:sldIdLst>
             <p14:sldId id="264"/>
           </p14:sldIdLst>
@@ -4085,7 +4085,7 @@
                   <a:schemeClr val="tx1"/>
                 </a:solidFill>
               </a:rPr>
-              <a:t>Reveal the states</a:t>
+              <a:t>See the states</a:t>
             </a:r>
             <a:endParaRPr lang="en-US" sz="1600" dirty="0"/>
           </a:p>
@@ -4099,7 +4099,7 @@
                   <a:schemeClr val="tx2"/>
                 </a:solidFill>
               </a:rPr>
-              <a:t>Show state boundaries to check the river's course</a:t>
+              <a:t>State boundaries show which states each river flows through</a:t>
             </a:r>
             <a:endParaRPr lang="en-US" sz="1600" dirty="0"/>
           </a:p>

</xml_diff>